<commit_message>
Add a new slide detailing dataset importance and active learning costs
Adds a new 5th slide to the presentation which emphasizes the critical role and cost of dataset acquisition and the ongoing need for funding to support active learning cycles, while also managing expectations regarding perfect accuracy.

Replit-Commit-Author: Agent
Replit-Commit-Session-Id: 6ede0d58-6595-48bd-b72a-9e64018177cd
Replit-Commit-Checkpoint-Type: full_checkpoint
Replit-Commit-Event-Id: faa5168c-f33d-47b5-9177-518b29c405c0
Replit-Commit-Screenshot-Url: https://storage.googleapis.com/screenshot-production-us-central1/1ae31300-7c48-4a8a-bbb7-f1f0ab58e9d3/6ede0d58-6595-48bd-b72a-9e64018177cd/NO9t4AA
Replit-Helium-Checkpoint-Created: true
</commit_message>
<xml_diff>
--- a/exports/lotusbio_tti_demo.pptx
+++ b/exports/lotusbio_tti_demo.pptx
@@ -9,9 +9,10 @@
     <p:sldId id="257" r:id="rId3"/>
     <p:sldId id="258" r:id="rId4"/>
     <p:sldId id="259" r:id="rId5"/>
+    <p:sldId id="260" r:id="rId6"/>
   </p:sldIdLst>
   <p:notesMasterIdLst>
-    <p:notesMasterId r:id="rId6"/>
+    <p:notesMasterId r:id="rId7"/>
   </p:notesMasterIdLst>
   <p:sldSz cx="12192000" cy="6858000"/>
   <p:notesSz cx="6858000" cy="12192000"/>
@@ -793,6 +794,94 @@
             <a:fld id="{F7021451-1387-4CA6-816F-3879F97B5CBC}" type="slidenum">
               <a:rPr lang="en-US"/>
               <a:t>4</a:t>
+            </a:fld>
+            <a:endParaRPr lang="en-US"/>
+          </a:p>
+        </p:txBody>
+      </p:sp>
+    </p:spTree>
+    <p:extLst>
+      <p:ext uri="{BB962C8B-B14F-4D97-AF65-F5344CB8AC3E}">
+        <p14:creationId xmlns:p14="http://schemas.microsoft.com/office/powerpoint/2010/main" val="1024086991"/>
+      </p:ext>
+    </p:extLst>
+  </p:cSld>
+  <p:clrMapOvr>
+    <a:masterClrMapping/>
+  </p:clrMapOvr>
+</p:notes>
+</file>
+
+<file path=ppt/notesSlides/notesSlide5.xml><?xml version="1.0" encoding="utf-8"?>
+<p:notes xmlns:a="http://schemas.openxmlformats.org/drawingml/2006/main" xmlns:r="http://schemas.openxmlformats.org/officeDocument/2006/relationships" xmlns:p="http://schemas.openxmlformats.org/presentationml/2006/main">
+  <p:cSld>
+    <p:spTree>
+      <p:nvGrpSpPr>
+        <p:cNvPr id="1" name=""/>
+        <p:cNvGrpSpPr/>
+        <p:nvPr/>
+      </p:nvGrpSpPr>
+      <p:grpSpPr>
+        <a:xfrm>
+          <a:off x="0" y="0"/>
+          <a:ext cx="0" cy="0"/>
+          <a:chOff x="0" y="0"/>
+          <a:chExt cx="0" cy="0"/>
+        </a:xfrm>
+      </p:grpSpPr>
+      <p:sp>
+        <p:nvSpPr>
+          <p:cNvPr id="2" name="Slide Image Placeholder 1"/>
+          <p:cNvSpPr>
+            <a:spLocks noGrp="1" noRot="1" noChangeAspect="1"/>
+          </p:cNvSpPr>
+          <p:nvPr>
+            <p:ph type="sldImg"/>
+          </p:nvPr>
+        </p:nvSpPr>
+        <p:spPr/>
+      </p:sp>
+      <p:sp>
+        <p:nvSpPr>
+          <p:cNvPr id="3" name="Notes Placeholder 2"/>
+          <p:cNvSpPr>
+            <a:spLocks noGrp="1"/>
+          </p:cNvSpPr>
+          <p:nvPr>
+            <p:ph type="body" idx="1"/>
+          </p:nvPr>
+        </p:nvSpPr>
+        <p:spPr/>
+        <p:txBody>
+          <a:bodyPr/>
+          <a:lstStyle/>
+          <a:p>
+            <a:r>
+              <a:rPr lang="en-US" dirty="0"/>
+              <a:t/>
+            </a:r>
+            <a:endParaRPr lang="en-US" dirty="0"/>
+          </a:p>
+        </p:txBody>
+      </p:sp>
+      <p:sp>
+        <p:nvSpPr>
+          <p:cNvPr id="4" name="Slide Number Placeholder 3"/>
+          <p:cNvSpPr>
+            <a:spLocks noGrp="1"/>
+          </p:cNvSpPr>
+          <p:nvPr>
+            <p:ph type="sldNum" sz="quarter" idx="10"/>
+          </p:nvPr>
+        </p:nvSpPr>
+        <p:spPr/>
+        <p:txBody>
+          <a:bodyPr/>
+          <a:lstStyle/>
+          <a:p>
+            <a:fld id="{F7021451-1387-4CA6-816F-3879F97B5CBC}" type="slidenum">
+              <a:rPr lang="en-US"/>
+              <a:t>5</a:t>
             </a:fld>
             <a:endParaRPr lang="en-US"/>
           </a:p>
@@ -2395,7 +2484,7 @@
                 <a:ea typeface="Malgun Gothic" pitchFamily="34" charset="-122"/>
                 <a:cs typeface="Malgun Gothic" pitchFamily="34" charset="-120"/>
               </a:rPr>
-              <a:t>p.1 / 4</a:t>
+              <a:t>1 / 5</a:t>
             </a:r>
             <a:endParaRPr lang="en-US" sz="900" dirty="0"/>
           </a:p>
@@ -2569,7 +2658,7 @@
                 <a:ea typeface="Malgun Gothic" pitchFamily="34" charset="-122"/>
                 <a:cs typeface="Malgun Gothic" pitchFamily="34" charset="-120"/>
               </a:rPr>
-              <a:t>2 / 4</a:t>
+              <a:t>2 / 5</a:t>
             </a:r>
             <a:endParaRPr lang="en-US" sz="900" dirty="0"/>
           </a:p>
@@ -4405,7 +4494,7 @@
                 <a:ea typeface="Malgun Gothic" pitchFamily="34" charset="-122"/>
                 <a:cs typeface="Malgun Gothic" pitchFamily="34" charset="-120"/>
               </a:rPr>
-              <a:t>3 / 4</a:t>
+              <a:t>3 / 5</a:t>
             </a:r>
             <a:endParaRPr lang="en-US" sz="900" dirty="0"/>
           </a:p>
@@ -6640,7 +6729,7 @@
                 <a:ea typeface="Malgun Gothic" pitchFamily="34" charset="-122"/>
                 <a:cs typeface="Malgun Gothic" pitchFamily="34" charset="-120"/>
               </a:rPr>
-              <a:t>4 / 4</a:t>
+              <a:t>4 / 5</a:t>
             </a:r>
             <a:endParaRPr lang="en-US" sz="900" dirty="0"/>
           </a:p>
@@ -8846,6 +8935,1995 @@
               <a:t>B2B 파일럿</a:t>
             </a:r>
             <a:endParaRPr lang="en-US" sz="950" dirty="0"/>
+          </a:p>
+        </p:txBody>
+      </p:sp>
+    </p:spTree>
+  </p:cSld>
+  <p:clrMapOvr>
+    <a:masterClrMapping/>
+  </p:clrMapOvr>
+</p:sld>
+</file>
+
+<file path=ppt/slides/slide5.xml><?xml version="1.0" encoding="utf-8"?>
+<p:sld xmlns:a="http://schemas.openxmlformats.org/drawingml/2006/main" xmlns:r="http://schemas.openxmlformats.org/officeDocument/2006/relationships" xmlns:p="http://schemas.openxmlformats.org/presentationml/2006/main">
+  <p:cSld name="Slide 5">
+    <p:bg>
+      <p:bgPr>
+        <a:solidFill>
+          <a:srgbClr val="FFFFFF"/>
+        </a:solidFill>
+      </p:bgPr>
+    </p:bg>
+    <p:spTree>
+      <p:nvGrpSpPr>
+        <p:cNvPr id="1" name=""/>
+        <p:cNvGrpSpPr/>
+        <p:nvPr/>
+      </p:nvGrpSpPr>
+      <p:grpSpPr>
+        <a:xfrm>
+          <a:off x="0" y="0"/>
+          <a:ext cx="0" cy="0"/>
+          <a:chOff x="0" y="0"/>
+          <a:chExt cx="0" cy="0"/>
+        </a:xfrm>
+      </p:grpSpPr>
+      <p:sp>
+        <p:nvSpPr>
+          <p:cNvPr id="2" name="Shape 0"/>
+          <p:cNvSpPr/>
+          <p:nvPr/>
+        </p:nvSpPr>
+        <p:spPr>
+          <a:xfrm>
+            <a:off x="0" y="0"/>
+            <a:ext cx="12191695" cy="45720"/>
+          </a:xfrm>
+          <a:prstGeom prst="rect">
+            <a:avLst/>
+          </a:prstGeom>
+          <a:solidFill>
+            <a:srgbClr val="0E5C8A"/>
+          </a:solidFill>
+          <a:ln w="12700">
+            <a:solidFill>
+              <a:srgbClr val="0E5C8A"/>
+            </a:solidFill>
+            <a:prstDash val="solid"/>
+          </a:ln>
+        </p:spPr>
+      </p:sp>
+      <p:sp>
+        <p:nvSpPr>
+          <p:cNvPr id="3" name="Text 1"/>
+          <p:cNvSpPr/>
+          <p:nvPr/>
+        </p:nvSpPr>
+        <p:spPr>
+          <a:xfrm>
+            <a:off x="365760" y="164592"/>
+            <a:ext cx="3657600" cy="274320"/>
+          </a:xfrm>
+          <a:prstGeom prst="rect">
+            <a:avLst/>
+          </a:prstGeom>
+          <a:noFill/>
+          <a:ln/>
+        </p:spPr>
+        <p:txBody>
+          <a:bodyPr wrap="square" rtlCol="0" anchor="ctr"/>
+          <a:lstStyle/>
+          <a:p>
+            <a:pPr indent="0" marL="0">
+              <a:buNone/>
+            </a:pPr>
+            <a:r>
+              <a:rPr lang="en-US" sz="1000" dirty="0">
+                <a:solidFill>
+                  <a:srgbClr val="6B7785"/>
+                </a:solidFill>
+                <a:latin typeface="Malgun Gothic" pitchFamily="34" charset="0"/>
+                <a:ea typeface="Malgun Gothic" pitchFamily="34" charset="-122"/>
+                <a:cs typeface="Malgun Gothic" pitchFamily="34" charset="-120"/>
+              </a:rPr>
+              <a:t>Lotusbio · TTI AI Scanner</a:t>
+            </a:r>
+            <a:endParaRPr lang="en-US" sz="1000" dirty="0"/>
+          </a:p>
+        </p:txBody>
+      </p:sp>
+      <p:sp>
+        <p:nvSpPr>
+          <p:cNvPr id="4" name="Text 2"/>
+          <p:cNvSpPr/>
+          <p:nvPr/>
+        </p:nvSpPr>
+        <p:spPr>
+          <a:xfrm>
+            <a:off x="8991295" y="164592"/>
+            <a:ext cx="2834640" cy="274320"/>
+          </a:xfrm>
+          <a:prstGeom prst="rect">
+            <a:avLst/>
+          </a:prstGeom>
+          <a:noFill/>
+          <a:ln/>
+        </p:spPr>
+        <p:txBody>
+          <a:bodyPr wrap="square" rtlCol="0" anchor="ctr"/>
+          <a:lstStyle/>
+          <a:p>
+            <a:pPr algn="r" indent="0" marL="0">
+              <a:buNone/>
+            </a:pPr>
+            <a:r>
+              <a:rPr lang="en-US" sz="1000" spc="200" kern="0" dirty="0">
+                <a:solidFill>
+                  <a:srgbClr val="6B7785"/>
+                </a:solidFill>
+                <a:latin typeface="Malgun Gothic" pitchFamily="34" charset="0"/>
+                <a:ea typeface="Malgun Gothic" pitchFamily="34" charset="-122"/>
+                <a:cs typeface="Malgun Gothic" pitchFamily="34" charset="-120"/>
+              </a:rPr>
+              <a:t>INVESTOR DECK · 2026</a:t>
+            </a:r>
+            <a:endParaRPr lang="en-US" sz="1000" dirty="0"/>
+          </a:p>
+        </p:txBody>
+      </p:sp>
+      <p:sp>
+        <p:nvSpPr>
+          <p:cNvPr id="5" name="Text 3"/>
+          <p:cNvSpPr/>
+          <p:nvPr/>
+        </p:nvSpPr>
+        <p:spPr>
+          <a:xfrm>
+            <a:off x="11277295" y="6492240"/>
+            <a:ext cx="548640" cy="274320"/>
+          </a:xfrm>
+          <a:prstGeom prst="rect">
+            <a:avLst/>
+          </a:prstGeom>
+          <a:noFill/>
+          <a:ln/>
+        </p:spPr>
+        <p:txBody>
+          <a:bodyPr wrap="square" rtlCol="0" anchor="ctr"/>
+          <a:lstStyle/>
+          <a:p>
+            <a:pPr algn="r" indent="0" marL="0">
+              <a:buNone/>
+            </a:pPr>
+            <a:r>
+              <a:rPr lang="en-US" sz="900" dirty="0">
+                <a:solidFill>
+                  <a:srgbClr val="6B7785"/>
+                </a:solidFill>
+                <a:latin typeface="Malgun Gothic" pitchFamily="34" charset="0"/>
+                <a:ea typeface="Malgun Gothic" pitchFamily="34" charset="-122"/>
+                <a:cs typeface="Malgun Gothic" pitchFamily="34" charset="-120"/>
+              </a:rPr>
+              <a:t>5 / 5</a:t>
+            </a:r>
+            <a:endParaRPr lang="en-US" sz="900" dirty="0"/>
+          </a:p>
+        </p:txBody>
+      </p:sp>
+      <p:sp>
+        <p:nvSpPr>
+          <p:cNvPr id="6" name="Text 4"/>
+          <p:cNvSpPr/>
+          <p:nvPr/>
+        </p:nvSpPr>
+        <p:spPr>
+          <a:xfrm>
+            <a:off x="457200" y="502920"/>
+            <a:ext cx="11277295" cy="548640"/>
+          </a:xfrm>
+          <a:prstGeom prst="rect">
+            <a:avLst/>
+          </a:prstGeom>
+          <a:noFill/>
+          <a:ln/>
+        </p:spPr>
+        <p:txBody>
+          <a:bodyPr wrap="square" rtlCol="0" anchor="ctr"/>
+          <a:lstStyle/>
+          <a:p>
+            <a:pPr indent="0" marL="0">
+              <a:buNone/>
+            </a:pPr>
+            <a:r>
+              <a:rPr lang="en-US" sz="2800" b="1" dirty="0">
+                <a:solidFill>
+                  <a:srgbClr val="1A2B3C"/>
+                </a:solidFill>
+                <a:latin typeface="Malgun Gothic" pitchFamily="34" charset="0"/>
+                <a:ea typeface="Malgun Gothic" pitchFamily="34" charset="-122"/>
+                <a:cs typeface="Malgun Gothic" pitchFamily="34" charset="-120"/>
+              </a:rPr>
+              <a:t>왜 지속적인 투자가 필요한가</a:t>
+            </a:r>
+            <a:endParaRPr lang="en-US" sz="2800" dirty="0"/>
+          </a:p>
+        </p:txBody>
+      </p:sp>
+      <p:sp>
+        <p:nvSpPr>
+          <p:cNvPr id="7" name="Text 5"/>
+          <p:cNvSpPr/>
+          <p:nvPr/>
+        </p:nvSpPr>
+        <p:spPr>
+          <a:xfrm>
+            <a:off x="457200" y="1051560"/>
+            <a:ext cx="11277295" cy="320040"/>
+          </a:xfrm>
+          <a:prstGeom prst="rect">
+            <a:avLst/>
+          </a:prstGeom>
+          <a:noFill/>
+          <a:ln/>
+        </p:spPr>
+        <p:txBody>
+          <a:bodyPr wrap="square" rtlCol="0" anchor="ctr"/>
+          <a:lstStyle/>
+          <a:p>
+            <a:pPr indent="0" marL="0">
+              <a:buNone/>
+            </a:pPr>
+            <a:r>
+              <a:rPr lang="en-US" sz="1300" dirty="0">
+                <a:solidFill>
+                  <a:srgbClr val="6B7785"/>
+                </a:solidFill>
+                <a:latin typeface="Malgun Gothic" pitchFamily="34" charset="0"/>
+                <a:ea typeface="Malgun Gothic" pitchFamily="34" charset="-122"/>
+                <a:cs typeface="Malgun Gothic" pitchFamily="34" charset="-120"/>
+              </a:rPr>
+              <a:t>AI 정확도의 핵심은 모델이 아니라 데이터 — 한 번 만들고 끝나는 사업이 아닙니다</a:t>
+            </a:r>
+            <a:endParaRPr lang="en-US" sz="1300" dirty="0"/>
+          </a:p>
+        </p:txBody>
+      </p:sp>
+      <p:sp>
+        <p:nvSpPr>
+          <p:cNvPr id="8" name="Shape 6"/>
+          <p:cNvSpPr/>
+          <p:nvPr/>
+        </p:nvSpPr>
+        <p:spPr>
+          <a:xfrm>
+            <a:off x="457200" y="1417320"/>
+            <a:ext cx="548640" cy="54864"/>
+          </a:xfrm>
+          <a:prstGeom prst="rect">
+            <a:avLst/>
+          </a:prstGeom>
+          <a:solidFill>
+            <a:srgbClr val="4FB3BF"/>
+          </a:solidFill>
+          <a:ln w="12700">
+            <a:solidFill>
+              <a:srgbClr val="4FB3BF"/>
+            </a:solidFill>
+            <a:prstDash val="solid"/>
+          </a:ln>
+        </p:spPr>
+      </p:sp>
+      <p:sp>
+        <p:nvSpPr>
+          <p:cNvPr id="9" name="Shape 7"/>
+          <p:cNvSpPr/>
+          <p:nvPr/>
+        </p:nvSpPr>
+        <p:spPr>
+          <a:xfrm>
+            <a:off x="457200" y="1828800"/>
+            <a:ext cx="5532120" cy="2331720"/>
+          </a:xfrm>
+          <a:prstGeom prst="roundRect">
+            <a:avLst>
+              <a:gd name="adj" fmla="val 5882"/>
+            </a:avLst>
+          </a:prstGeom>
+          <a:solidFill>
+            <a:srgbClr val="E8F1F4"/>
+          </a:solidFill>
+          <a:ln w="15240">
+            <a:solidFill>
+              <a:srgbClr val="0E5C8A"/>
+            </a:solidFill>
+            <a:prstDash val="solid"/>
+          </a:ln>
+        </p:spPr>
+      </p:sp>
+      <p:sp>
+        <p:nvSpPr>
+          <p:cNvPr id="10" name="Shape 8"/>
+          <p:cNvSpPr/>
+          <p:nvPr/>
+        </p:nvSpPr>
+        <p:spPr>
+          <a:xfrm>
+            <a:off x="457200" y="1828800"/>
+            <a:ext cx="5532120" cy="457200"/>
+          </a:xfrm>
+          <a:prstGeom prst="rect">
+            <a:avLst/>
+          </a:prstGeom>
+          <a:solidFill>
+            <a:srgbClr val="0E5C8A"/>
+          </a:solidFill>
+          <a:ln w="12700">
+            <a:solidFill>
+              <a:srgbClr val="0E5C8A"/>
+            </a:solidFill>
+            <a:prstDash val="solid"/>
+          </a:ln>
+        </p:spPr>
+      </p:sp>
+      <p:sp>
+        <p:nvSpPr>
+          <p:cNvPr id="11" name="Text 9"/>
+          <p:cNvSpPr/>
+          <p:nvPr/>
+        </p:nvSpPr>
+        <p:spPr>
+          <a:xfrm>
+            <a:off x="640080" y="1874520"/>
+            <a:ext cx="5166360" cy="365760"/>
+          </a:xfrm>
+          <a:prstGeom prst="rect">
+            <a:avLst/>
+          </a:prstGeom>
+          <a:noFill/>
+          <a:ln/>
+        </p:spPr>
+        <p:txBody>
+          <a:bodyPr wrap="square" rtlCol="0" anchor="ctr"/>
+          <a:lstStyle/>
+          <a:p>
+            <a:pPr indent="0" marL="0">
+              <a:buNone/>
+            </a:pPr>
+            <a:r>
+              <a:rPr lang="en-US" sz="1100" b="1" spc="100" kern="0" dirty="0">
+                <a:solidFill>
+                  <a:srgbClr val="FFFFFF"/>
+                </a:solidFill>
+                <a:latin typeface="Malgun Gothic" pitchFamily="34" charset="0"/>
+                <a:ea typeface="Malgun Gothic" pitchFamily="34" charset="-122"/>
+                <a:cs typeface="Malgun Gothic" pitchFamily="34" charset="-120"/>
+              </a:rPr>
+              <a:t>STEP 1 — 데이터셋 확보 (가장 큰 자본 집행)</a:t>
+            </a:r>
+            <a:endParaRPr lang="en-US" sz="1100" dirty="0"/>
+          </a:p>
+        </p:txBody>
+      </p:sp>
+      <p:sp>
+        <p:nvSpPr>
+          <p:cNvPr id="12" name="Shape 10"/>
+          <p:cNvSpPr/>
+          <p:nvPr/>
+        </p:nvSpPr>
+        <p:spPr>
+          <a:xfrm>
+            <a:off x="685800" y="2468880"/>
+            <a:ext cx="1569720" cy="1554480"/>
+          </a:xfrm>
+          <a:prstGeom prst="rect">
+            <a:avLst/>
+          </a:prstGeom>
+          <a:solidFill>
+            <a:srgbClr val="FFFFFF"/>
+          </a:solidFill>
+          <a:ln w="6350">
+            <a:solidFill>
+              <a:srgbClr val="CFDCE2"/>
+            </a:solidFill>
+            <a:prstDash val="solid"/>
+          </a:ln>
+        </p:spPr>
+      </p:sp>
+      <p:sp>
+        <p:nvSpPr>
+          <p:cNvPr id="13" name="Text 11"/>
+          <p:cNvSpPr/>
+          <p:nvPr/>
+        </p:nvSpPr>
+        <p:spPr>
+          <a:xfrm>
+            <a:off x="685800" y="2560320"/>
+            <a:ext cx="1569720" cy="502920"/>
+          </a:xfrm>
+          <a:prstGeom prst="rect">
+            <a:avLst/>
+          </a:prstGeom>
+          <a:noFill/>
+          <a:ln/>
+        </p:spPr>
+        <p:txBody>
+          <a:bodyPr wrap="square" rtlCol="0" anchor="ctr"/>
+          <a:lstStyle/>
+          <a:p>
+            <a:pPr algn="ctr" indent="0" marL="0">
+              <a:buNone/>
+            </a:pPr>
+            <a:r>
+              <a:rPr lang="en-US" sz="2200" b="1" dirty="0">
+                <a:solidFill>
+                  <a:srgbClr val="0E5C8A"/>
+                </a:solidFill>
+                <a:latin typeface="Malgun Gothic" pitchFamily="34" charset="0"/>
+                <a:ea typeface="Malgun Gothic" pitchFamily="34" charset="-122"/>
+                <a:cs typeface="Malgun Gothic" pitchFamily="34" charset="-120"/>
+              </a:rPr>
+              <a:t>30,000+</a:t>
+            </a:r>
+            <a:endParaRPr lang="en-US" sz="2200" dirty="0"/>
+          </a:p>
+        </p:txBody>
+      </p:sp>
+      <p:sp>
+        <p:nvSpPr>
+          <p:cNvPr id="14" name="Text 12"/>
+          <p:cNvSpPr/>
+          <p:nvPr/>
+        </p:nvSpPr>
+        <p:spPr>
+          <a:xfrm>
+            <a:off x="685800" y="3063240"/>
+            <a:ext cx="1569720" cy="274320"/>
+          </a:xfrm>
+          <a:prstGeom prst="rect">
+            <a:avLst/>
+          </a:prstGeom>
+          <a:noFill/>
+          <a:ln/>
+        </p:spPr>
+        <p:txBody>
+          <a:bodyPr wrap="square" rtlCol="0" anchor="ctr"/>
+          <a:lstStyle/>
+          <a:p>
+            <a:pPr algn="ctr" indent="0" marL="0">
+              <a:buNone/>
+            </a:pPr>
+            <a:r>
+              <a:rPr lang="en-US" sz="1050" b="1" dirty="0">
+                <a:solidFill>
+                  <a:srgbClr val="1A2B3C"/>
+                </a:solidFill>
+                <a:latin typeface="Malgun Gothic" pitchFamily="34" charset="0"/>
+                <a:ea typeface="Malgun Gothic" pitchFamily="34" charset="-122"/>
+                <a:cs typeface="Malgun Gothic" pitchFamily="34" charset="-120"/>
+              </a:rPr>
+              <a:t>라벨링 사진</a:t>
+            </a:r>
+            <a:endParaRPr lang="en-US" sz="1050" dirty="0"/>
+          </a:p>
+        </p:txBody>
+      </p:sp>
+      <p:sp>
+        <p:nvSpPr>
+          <p:cNvPr id="15" name="Text 13"/>
+          <p:cNvSpPr/>
+          <p:nvPr/>
+        </p:nvSpPr>
+        <p:spPr>
+          <a:xfrm>
+            <a:off x="731520" y="3337560"/>
+            <a:ext cx="1478280" cy="640080"/>
+          </a:xfrm>
+          <a:prstGeom prst="rect">
+            <a:avLst/>
+          </a:prstGeom>
+          <a:noFill/>
+          <a:ln/>
+        </p:spPr>
+        <p:txBody>
+          <a:bodyPr wrap="square" rtlCol="0" anchor="t"/>
+          <a:lstStyle/>
+          <a:p>
+            <a:pPr algn="ctr" indent="0" marL="0">
+              <a:buNone/>
+            </a:pPr>
+            <a:r>
+              <a:rPr lang="en-US" sz="900" dirty="0">
+                <a:solidFill>
+                  <a:srgbClr val="6B7785"/>
+                </a:solidFill>
+                <a:latin typeface="Malgun Gothic" pitchFamily="34" charset="0"/>
+                <a:ea typeface="Malgun Gothic" pitchFamily="34" charset="-122"/>
+                <a:cs typeface="Malgun Gothic" pitchFamily="34" charset="-120"/>
+              </a:rPr>
+              <a:t>조명·각도·배경·</a:t>
+            </a:r>
+            <a:endParaRPr lang="en-US" sz="900" dirty="0"/>
+          </a:p>
+          <a:p>
+            <a:pPr algn="ctr" indent="0" marL="0">
+              <a:buNone/>
+            </a:pPr>
+            <a:r>
+              <a:rPr lang="en-US" sz="900" dirty="0">
+                <a:solidFill>
+                  <a:srgbClr val="6B7785"/>
+                </a:solidFill>
+                <a:latin typeface="Malgun Gothic" pitchFamily="34" charset="0"/>
+                <a:ea typeface="Malgun Gothic" pitchFamily="34" charset="-122"/>
+                <a:cs typeface="Malgun Gothic" pitchFamily="34" charset="-120"/>
+              </a:rPr>
+              <a:t>포장재·부분 변색</a:t>
+            </a:r>
+            <a:endParaRPr lang="en-US" sz="900" dirty="0"/>
+          </a:p>
+        </p:txBody>
+      </p:sp>
+      <p:sp>
+        <p:nvSpPr>
+          <p:cNvPr id="16" name="Shape 14"/>
+          <p:cNvSpPr/>
+          <p:nvPr/>
+        </p:nvSpPr>
+        <p:spPr>
+          <a:xfrm>
+            <a:off x="2346960" y="2468880"/>
+            <a:ext cx="1569720" cy="1554480"/>
+          </a:xfrm>
+          <a:prstGeom prst="rect">
+            <a:avLst/>
+          </a:prstGeom>
+          <a:solidFill>
+            <a:srgbClr val="FFFFFF"/>
+          </a:solidFill>
+          <a:ln w="6350">
+            <a:solidFill>
+              <a:srgbClr val="CFDCE2"/>
+            </a:solidFill>
+            <a:prstDash val="solid"/>
+          </a:ln>
+        </p:spPr>
+      </p:sp>
+      <p:sp>
+        <p:nvSpPr>
+          <p:cNvPr id="17" name="Text 15"/>
+          <p:cNvSpPr/>
+          <p:nvPr/>
+        </p:nvSpPr>
+        <p:spPr>
+          <a:xfrm>
+            <a:off x="2346960" y="2560320"/>
+            <a:ext cx="1569720" cy="502920"/>
+          </a:xfrm>
+          <a:prstGeom prst="rect">
+            <a:avLst/>
+          </a:prstGeom>
+          <a:noFill/>
+          <a:ln/>
+        </p:spPr>
+        <p:txBody>
+          <a:bodyPr wrap="square" rtlCol="0" anchor="ctr"/>
+          <a:lstStyle/>
+          <a:p>
+            <a:pPr algn="ctr" indent="0" marL="0">
+              <a:buNone/>
+            </a:pPr>
+            <a:r>
+              <a:rPr lang="en-US" sz="2200" b="1" dirty="0">
+                <a:solidFill>
+                  <a:srgbClr val="0E5C8A"/>
+                </a:solidFill>
+                <a:latin typeface="Malgun Gothic" pitchFamily="34" charset="0"/>
+                <a:ea typeface="Malgun Gothic" pitchFamily="34" charset="-122"/>
+                <a:cs typeface="Malgun Gothic" pitchFamily="34" charset="-120"/>
+              </a:rPr>
+              <a:t>6 개월</a:t>
+            </a:r>
+            <a:endParaRPr lang="en-US" sz="2200" dirty="0"/>
+          </a:p>
+        </p:txBody>
+      </p:sp>
+      <p:sp>
+        <p:nvSpPr>
+          <p:cNvPr id="18" name="Text 16"/>
+          <p:cNvSpPr/>
+          <p:nvPr/>
+        </p:nvSpPr>
+        <p:spPr>
+          <a:xfrm>
+            <a:off x="2346960" y="3063240"/>
+            <a:ext cx="1569720" cy="274320"/>
+          </a:xfrm>
+          <a:prstGeom prst="rect">
+            <a:avLst/>
+          </a:prstGeom>
+          <a:noFill/>
+          <a:ln/>
+        </p:spPr>
+        <p:txBody>
+          <a:bodyPr wrap="square" rtlCol="0" anchor="ctr"/>
+          <a:lstStyle/>
+          <a:p>
+            <a:pPr algn="ctr" indent="0" marL="0">
+              <a:buNone/>
+            </a:pPr>
+            <a:r>
+              <a:rPr lang="en-US" sz="1050" b="1" dirty="0">
+                <a:solidFill>
+                  <a:srgbClr val="1A2B3C"/>
+                </a:solidFill>
+                <a:latin typeface="Malgun Gothic" pitchFamily="34" charset="0"/>
+                <a:ea typeface="Malgun Gothic" pitchFamily="34" charset="-122"/>
+                <a:cs typeface="Malgun Gothic" pitchFamily="34" charset="-120"/>
+              </a:rPr>
+              <a:t>수집·라벨링 기간</a:t>
+            </a:r>
+            <a:endParaRPr lang="en-US" sz="1050" dirty="0"/>
+          </a:p>
+        </p:txBody>
+      </p:sp>
+      <p:sp>
+        <p:nvSpPr>
+          <p:cNvPr id="19" name="Text 17"/>
+          <p:cNvSpPr/>
+          <p:nvPr/>
+        </p:nvSpPr>
+        <p:spPr>
+          <a:xfrm>
+            <a:off x="2392680" y="3337560"/>
+            <a:ext cx="1478280" cy="640080"/>
+          </a:xfrm>
+          <a:prstGeom prst="rect">
+            <a:avLst/>
+          </a:prstGeom>
+          <a:noFill/>
+          <a:ln/>
+        </p:spPr>
+        <p:txBody>
+          <a:bodyPr wrap="square" rtlCol="0" anchor="t"/>
+          <a:lstStyle/>
+          <a:p>
+            <a:pPr algn="ctr" indent="0" marL="0">
+              <a:buNone/>
+            </a:pPr>
+            <a:r>
+              <a:rPr lang="en-US" sz="900" dirty="0">
+                <a:solidFill>
+                  <a:srgbClr val="6B7785"/>
+                </a:solidFill>
+                <a:latin typeface="Malgun Gothic" pitchFamily="34" charset="0"/>
+                <a:ea typeface="Malgun Gothic" pitchFamily="34" charset="-122"/>
+                <a:cs typeface="Malgun Gothic" pitchFamily="34" charset="-120"/>
+              </a:rPr>
+              <a:t>전문 라벨러 +</a:t>
+            </a:r>
+            <a:endParaRPr lang="en-US" sz="900" dirty="0"/>
+          </a:p>
+          <a:p>
+            <a:pPr algn="ctr" indent="0" marL="0">
+              <a:buNone/>
+            </a:pPr>
+            <a:r>
+              <a:rPr lang="en-US" sz="900" dirty="0">
+                <a:solidFill>
+                  <a:srgbClr val="6B7785"/>
+                </a:solidFill>
+                <a:latin typeface="Malgun Gothic" pitchFamily="34" charset="0"/>
+                <a:ea typeface="Malgun Gothic" pitchFamily="34" charset="-122"/>
+                <a:cs typeface="Malgun Gothic" pitchFamily="34" charset="-120"/>
+              </a:rPr>
+              <a:t>식품공학 검수</a:t>
+            </a:r>
+            <a:endParaRPr lang="en-US" sz="900" dirty="0"/>
+          </a:p>
+        </p:txBody>
+      </p:sp>
+      <p:sp>
+        <p:nvSpPr>
+          <p:cNvPr id="20" name="Shape 18"/>
+          <p:cNvSpPr/>
+          <p:nvPr/>
+        </p:nvSpPr>
+        <p:spPr>
+          <a:xfrm>
+            <a:off x="4008120" y="2468880"/>
+            <a:ext cx="1569720" cy="1554480"/>
+          </a:xfrm>
+          <a:prstGeom prst="rect">
+            <a:avLst/>
+          </a:prstGeom>
+          <a:solidFill>
+            <a:srgbClr val="FFFFFF"/>
+          </a:solidFill>
+          <a:ln w="6350">
+            <a:solidFill>
+              <a:srgbClr val="CFDCE2"/>
+            </a:solidFill>
+            <a:prstDash val="solid"/>
+          </a:ln>
+        </p:spPr>
+      </p:sp>
+      <p:sp>
+        <p:nvSpPr>
+          <p:cNvPr id="21" name="Text 19"/>
+          <p:cNvSpPr/>
+          <p:nvPr/>
+        </p:nvSpPr>
+        <p:spPr>
+          <a:xfrm>
+            <a:off x="4008120" y="2560320"/>
+            <a:ext cx="1569720" cy="502920"/>
+          </a:xfrm>
+          <a:prstGeom prst="rect">
+            <a:avLst/>
+          </a:prstGeom>
+          <a:noFill/>
+          <a:ln/>
+        </p:spPr>
+        <p:txBody>
+          <a:bodyPr wrap="square" rtlCol="0" anchor="ctr"/>
+          <a:lstStyle/>
+          <a:p>
+            <a:pPr algn="ctr" indent="0" marL="0">
+              <a:buNone/>
+            </a:pPr>
+            <a:r>
+              <a:rPr lang="en-US" sz="2200" b="1" dirty="0">
+                <a:solidFill>
+                  <a:srgbClr val="0E5C8A"/>
+                </a:solidFill>
+                <a:latin typeface="Malgun Gothic" pitchFamily="34" charset="0"/>
+                <a:ea typeface="Malgun Gothic" pitchFamily="34" charset="-122"/>
+                <a:cs typeface="Malgun Gothic" pitchFamily="34" charset="-120"/>
+              </a:rPr>
+              <a:t>₩4 억+</a:t>
+            </a:r>
+            <a:endParaRPr lang="en-US" sz="2200" dirty="0"/>
+          </a:p>
+        </p:txBody>
+      </p:sp>
+      <p:sp>
+        <p:nvSpPr>
+          <p:cNvPr id="22" name="Text 20"/>
+          <p:cNvSpPr/>
+          <p:nvPr/>
+        </p:nvSpPr>
+        <p:spPr>
+          <a:xfrm>
+            <a:off x="4008120" y="3063240"/>
+            <a:ext cx="1569720" cy="274320"/>
+          </a:xfrm>
+          <a:prstGeom prst="rect">
+            <a:avLst/>
+          </a:prstGeom>
+          <a:noFill/>
+          <a:ln/>
+        </p:spPr>
+        <p:txBody>
+          <a:bodyPr wrap="square" rtlCol="0" anchor="ctr"/>
+          <a:lstStyle/>
+          <a:p>
+            <a:pPr algn="ctr" indent="0" marL="0">
+              <a:buNone/>
+            </a:pPr>
+            <a:r>
+              <a:rPr lang="en-US" sz="1050" b="1" dirty="0">
+                <a:solidFill>
+                  <a:srgbClr val="1A2B3C"/>
+                </a:solidFill>
+                <a:latin typeface="Malgun Gothic" pitchFamily="34" charset="0"/>
+                <a:ea typeface="Malgun Gothic" pitchFamily="34" charset="-122"/>
+                <a:cs typeface="Malgun Gothic" pitchFamily="34" charset="-120"/>
+              </a:rPr>
+              <a:t>추정 데이터 비용</a:t>
+            </a:r>
+            <a:endParaRPr lang="en-US" sz="1050" dirty="0"/>
+          </a:p>
+        </p:txBody>
+      </p:sp>
+      <p:sp>
+        <p:nvSpPr>
+          <p:cNvPr id="23" name="Text 21"/>
+          <p:cNvSpPr/>
+          <p:nvPr/>
+        </p:nvSpPr>
+        <p:spPr>
+          <a:xfrm>
+            <a:off x="4053840" y="3337560"/>
+            <a:ext cx="1478280" cy="640080"/>
+          </a:xfrm>
+          <a:prstGeom prst="rect">
+            <a:avLst/>
+          </a:prstGeom>
+          <a:noFill/>
+          <a:ln/>
+        </p:spPr>
+        <p:txBody>
+          <a:bodyPr wrap="square" rtlCol="0" anchor="t"/>
+          <a:lstStyle/>
+          <a:p>
+            <a:pPr algn="ctr" indent="0" marL="0">
+              <a:buNone/>
+            </a:pPr>
+            <a:r>
+              <a:rPr lang="en-US" sz="900" dirty="0">
+                <a:solidFill>
+                  <a:srgbClr val="6B7785"/>
+                </a:solidFill>
+                <a:latin typeface="Malgun Gothic" pitchFamily="34" charset="0"/>
+                <a:ea typeface="Malgun Gothic" pitchFamily="34" charset="-122"/>
+                <a:cs typeface="Malgun Gothic" pitchFamily="34" charset="-120"/>
+              </a:rPr>
+              <a:t>라벨링 외주 +</a:t>
+            </a:r>
+            <a:endParaRPr lang="en-US" sz="900" dirty="0"/>
+          </a:p>
+          <a:p>
+            <a:pPr algn="ctr" indent="0" marL="0">
+              <a:buNone/>
+            </a:pPr>
+            <a:r>
+              <a:rPr lang="en-US" sz="900" dirty="0">
+                <a:solidFill>
+                  <a:srgbClr val="6B7785"/>
+                </a:solidFill>
+                <a:latin typeface="Malgun Gothic" pitchFamily="34" charset="0"/>
+                <a:ea typeface="Malgun Gothic" pitchFamily="34" charset="-122"/>
+                <a:cs typeface="Malgun Gothic" pitchFamily="34" charset="-120"/>
+              </a:rPr>
+              <a:t>현장 촬영 + 검수</a:t>
+            </a:r>
+            <a:endParaRPr lang="en-US" sz="900" dirty="0"/>
+          </a:p>
+        </p:txBody>
+      </p:sp>
+      <p:sp>
+        <p:nvSpPr>
+          <p:cNvPr id="24" name="Shape 22"/>
+          <p:cNvSpPr/>
+          <p:nvPr/>
+        </p:nvSpPr>
+        <p:spPr>
+          <a:xfrm>
+            <a:off x="6202375" y="1828800"/>
+            <a:ext cx="5532120" cy="2331720"/>
+          </a:xfrm>
+          <a:prstGeom prst="roundRect">
+            <a:avLst>
+              <a:gd name="adj" fmla="val 5882"/>
+            </a:avLst>
+          </a:prstGeom>
+          <a:solidFill>
+            <a:srgbClr val="DCEFE5"/>
+          </a:solidFill>
+          <a:ln w="15240">
+            <a:solidFill>
+              <a:srgbClr val="2E7D5B"/>
+            </a:solidFill>
+            <a:prstDash val="solid"/>
+          </a:ln>
+        </p:spPr>
+      </p:sp>
+      <p:sp>
+        <p:nvSpPr>
+          <p:cNvPr id="25" name="Shape 23"/>
+          <p:cNvSpPr/>
+          <p:nvPr/>
+        </p:nvSpPr>
+        <p:spPr>
+          <a:xfrm>
+            <a:off x="6202375" y="1828800"/>
+            <a:ext cx="5532120" cy="457200"/>
+          </a:xfrm>
+          <a:prstGeom prst="rect">
+            <a:avLst/>
+          </a:prstGeom>
+          <a:solidFill>
+            <a:srgbClr val="2E7D5B"/>
+          </a:solidFill>
+          <a:ln w="12700">
+            <a:solidFill>
+              <a:srgbClr val="2E7D5B"/>
+            </a:solidFill>
+            <a:prstDash val="solid"/>
+          </a:ln>
+        </p:spPr>
+      </p:sp>
+      <p:sp>
+        <p:nvSpPr>
+          <p:cNvPr id="26" name="Text 24"/>
+          <p:cNvSpPr/>
+          <p:nvPr/>
+        </p:nvSpPr>
+        <p:spPr>
+          <a:xfrm>
+            <a:off x="6385255" y="1874520"/>
+            <a:ext cx="5166360" cy="365760"/>
+          </a:xfrm>
+          <a:prstGeom prst="rect">
+            <a:avLst/>
+          </a:prstGeom>
+          <a:noFill/>
+          <a:ln/>
+        </p:spPr>
+        <p:txBody>
+          <a:bodyPr wrap="square" rtlCol="0" anchor="ctr"/>
+          <a:lstStyle/>
+          <a:p>
+            <a:pPr indent="0" marL="0">
+              <a:buNone/>
+            </a:pPr>
+            <a:r>
+              <a:rPr lang="en-US" sz="1100" b="1" spc="100" kern="0" dirty="0">
+                <a:solidFill>
+                  <a:srgbClr val="FFFFFF"/>
+                </a:solidFill>
+                <a:latin typeface="Malgun Gothic" pitchFamily="34" charset="0"/>
+                <a:ea typeface="Malgun Gothic" pitchFamily="34" charset="-122"/>
+                <a:cs typeface="Malgun Gothic" pitchFamily="34" charset="-120"/>
+              </a:rPr>
+              <a:t>STEP 2 — Active Learning 사이클 (지속 운영비)</a:t>
+            </a:r>
+            <a:endParaRPr lang="en-US" sz="1100" dirty="0"/>
+          </a:p>
+        </p:txBody>
+      </p:sp>
+      <p:sp>
+        <p:nvSpPr>
+          <p:cNvPr id="27" name="Shape 25"/>
+          <p:cNvSpPr/>
+          <p:nvPr/>
+        </p:nvSpPr>
+        <p:spPr>
+          <a:xfrm>
+            <a:off x="8556955" y="2834640"/>
+            <a:ext cx="822960" cy="548640"/>
+          </a:xfrm>
+          <a:prstGeom prst="ellipse">
+            <a:avLst/>
+          </a:prstGeom>
+          <a:solidFill>
+            <a:srgbClr val="2E7D5B"/>
+          </a:solidFill>
+          <a:ln w="19050">
+            <a:solidFill>
+              <a:srgbClr val="FFFFFF"/>
+            </a:solidFill>
+            <a:prstDash val="solid"/>
+          </a:ln>
+        </p:spPr>
+      </p:sp>
+      <p:sp>
+        <p:nvSpPr>
+          <p:cNvPr id="28" name="Text 26"/>
+          <p:cNvSpPr/>
+          <p:nvPr/>
+        </p:nvSpPr>
+        <p:spPr>
+          <a:xfrm>
+            <a:off x="8511235" y="2852928"/>
+            <a:ext cx="914400" cy="502920"/>
+          </a:xfrm>
+          <a:prstGeom prst="rect">
+            <a:avLst/>
+          </a:prstGeom>
+          <a:noFill/>
+          <a:ln/>
+        </p:spPr>
+        <p:txBody>
+          <a:bodyPr wrap="square" rtlCol="0" anchor="ctr"/>
+          <a:lstStyle/>
+          <a:p>
+            <a:pPr algn="ctr" indent="0" marL="0">
+              <a:buNone/>
+            </a:pPr>
+            <a:r>
+              <a:rPr lang="en-US" sz="950" b="1" dirty="0">
+                <a:solidFill>
+                  <a:srgbClr val="FFFFFF"/>
+                </a:solidFill>
+                <a:latin typeface="Malgun Gothic" pitchFamily="34" charset="0"/>
+                <a:ea typeface="Malgun Gothic" pitchFamily="34" charset="-122"/>
+                <a:cs typeface="Malgun Gothic" pitchFamily="34" charset="-120"/>
+              </a:rPr>
+              <a:t>REPEAT</a:t>
+            </a:r>
+            <a:endParaRPr lang="en-US" sz="950" dirty="0"/>
+          </a:p>
+          <a:p>
+            <a:pPr algn="ctr" indent="0" marL="0">
+              <a:buNone/>
+            </a:pPr>
+            <a:r>
+              <a:rPr lang="en-US" sz="950" b="1" dirty="0">
+                <a:solidFill>
+                  <a:srgbClr val="FFFFFF"/>
+                </a:solidFill>
+                <a:latin typeface="Malgun Gothic" pitchFamily="34" charset="0"/>
+                <a:ea typeface="Malgun Gothic" pitchFamily="34" charset="-122"/>
+                <a:cs typeface="Malgun Gothic" pitchFamily="34" charset="-120"/>
+              </a:rPr>
+              <a:t>매 분기</a:t>
+            </a:r>
+            <a:endParaRPr lang="en-US" sz="950" dirty="0"/>
+          </a:p>
+        </p:txBody>
+      </p:sp>
+      <p:sp>
+        <p:nvSpPr>
+          <p:cNvPr id="29" name="Shape 27"/>
+          <p:cNvSpPr/>
+          <p:nvPr/>
+        </p:nvSpPr>
+        <p:spPr>
+          <a:xfrm>
+            <a:off x="8584387" y="2057400"/>
+            <a:ext cx="768096" cy="502920"/>
+          </a:xfrm>
+          <a:prstGeom prst="ellipse">
+            <a:avLst/>
+          </a:prstGeom>
+          <a:solidFill>
+            <a:srgbClr val="4FB3BF"/>
+          </a:solidFill>
+          <a:ln w="19050">
+            <a:solidFill>
+              <a:srgbClr val="FFFFFF"/>
+            </a:solidFill>
+            <a:prstDash val="solid"/>
+          </a:ln>
+        </p:spPr>
+      </p:sp>
+      <p:sp>
+        <p:nvSpPr>
+          <p:cNvPr id="30" name="Text 28"/>
+          <p:cNvSpPr/>
+          <p:nvPr/>
+        </p:nvSpPr>
+        <p:spPr>
+          <a:xfrm>
+            <a:off x="8465515" y="2039112"/>
+            <a:ext cx="1005840" cy="502920"/>
+          </a:xfrm>
+          <a:prstGeom prst="rect">
+            <a:avLst/>
+          </a:prstGeom>
+          <a:noFill/>
+          <a:ln/>
+        </p:spPr>
+        <p:txBody>
+          <a:bodyPr wrap="square" rtlCol="0" anchor="ctr"/>
+          <a:lstStyle/>
+          <a:p>
+            <a:pPr algn="ctr" indent="0" marL="0">
+              <a:buNone/>
+            </a:pPr>
+            <a:r>
+              <a:rPr lang="en-US" sz="850" b="1" dirty="0">
+                <a:solidFill>
+                  <a:srgbClr val="FFFFFF"/>
+                </a:solidFill>
+                <a:latin typeface="Malgun Gothic" pitchFamily="34" charset="0"/>
+                <a:ea typeface="Malgun Gothic" pitchFamily="34" charset="-122"/>
+                <a:cs typeface="Malgun Gothic" pitchFamily="34" charset="-120"/>
+              </a:rPr>
+              <a:t>사용자 촬영</a:t>
+            </a:r>
+            <a:endParaRPr lang="en-US" sz="850" dirty="0"/>
+          </a:p>
+          <a:p>
+            <a:pPr algn="ctr" indent="0" marL="0">
+              <a:buNone/>
+            </a:pPr>
+            <a:r>
+              <a:rPr lang="en-US" sz="850" b="1" dirty="0">
+                <a:solidFill>
+                  <a:srgbClr val="FFFFFF"/>
+                </a:solidFill>
+                <a:latin typeface="Malgun Gothic" pitchFamily="34" charset="0"/>
+                <a:ea typeface="Malgun Gothic" pitchFamily="34" charset="-122"/>
+                <a:cs typeface="Malgun Gothic" pitchFamily="34" charset="-120"/>
+              </a:rPr>
+              <a:t>수집</a:t>
+            </a:r>
+            <a:endParaRPr lang="en-US" sz="850" dirty="0"/>
+          </a:p>
+        </p:txBody>
+      </p:sp>
+      <p:sp>
+        <p:nvSpPr>
+          <p:cNvPr id="31" name="Shape 29"/>
+          <p:cNvSpPr/>
+          <p:nvPr/>
+        </p:nvSpPr>
+        <p:spPr>
+          <a:xfrm>
+            <a:off x="9361627" y="2834640"/>
+            <a:ext cx="768096" cy="502920"/>
+          </a:xfrm>
+          <a:prstGeom prst="ellipse">
+            <a:avLst/>
+          </a:prstGeom>
+          <a:solidFill>
+            <a:srgbClr val="C77E1E"/>
+          </a:solidFill>
+          <a:ln w="19050">
+            <a:solidFill>
+              <a:srgbClr val="FFFFFF"/>
+            </a:solidFill>
+            <a:prstDash val="solid"/>
+          </a:ln>
+        </p:spPr>
+      </p:sp>
+      <p:sp>
+        <p:nvSpPr>
+          <p:cNvPr id="32" name="Text 30"/>
+          <p:cNvSpPr/>
+          <p:nvPr/>
+        </p:nvSpPr>
+        <p:spPr>
+          <a:xfrm>
+            <a:off x="9242755" y="2816352"/>
+            <a:ext cx="1005840" cy="502920"/>
+          </a:xfrm>
+          <a:prstGeom prst="rect">
+            <a:avLst/>
+          </a:prstGeom>
+          <a:noFill/>
+          <a:ln/>
+        </p:spPr>
+        <p:txBody>
+          <a:bodyPr wrap="square" rtlCol="0" anchor="ctr"/>
+          <a:lstStyle/>
+          <a:p>
+            <a:pPr algn="ctr" indent="0" marL="0">
+              <a:buNone/>
+            </a:pPr>
+            <a:r>
+              <a:rPr lang="en-US" sz="850" b="1" dirty="0">
+                <a:solidFill>
+                  <a:srgbClr val="FFFFFF"/>
+                </a:solidFill>
+                <a:latin typeface="Malgun Gothic" pitchFamily="34" charset="0"/>
+                <a:ea typeface="Malgun Gothic" pitchFamily="34" charset="-122"/>
+                <a:cs typeface="Malgun Gothic" pitchFamily="34" charset="-120"/>
+              </a:rPr>
+              <a:t>낮은 신뢰도</a:t>
+            </a:r>
+            <a:endParaRPr lang="en-US" sz="850" dirty="0"/>
+          </a:p>
+          <a:p>
+            <a:pPr algn="ctr" indent="0" marL="0">
+              <a:buNone/>
+            </a:pPr>
+            <a:r>
+              <a:rPr lang="en-US" sz="850" b="1" dirty="0">
+                <a:solidFill>
+                  <a:srgbClr val="FFFFFF"/>
+                </a:solidFill>
+                <a:latin typeface="Malgun Gothic" pitchFamily="34" charset="0"/>
+                <a:ea typeface="Malgun Gothic" pitchFamily="34" charset="-122"/>
+                <a:cs typeface="Malgun Gothic" pitchFamily="34" charset="-120"/>
+              </a:rPr>
+              <a:t>샘플 추출</a:t>
+            </a:r>
+            <a:endParaRPr lang="en-US" sz="850" dirty="0"/>
+          </a:p>
+        </p:txBody>
+      </p:sp>
+      <p:sp>
+        <p:nvSpPr>
+          <p:cNvPr id="33" name="Shape 31"/>
+          <p:cNvSpPr/>
+          <p:nvPr/>
+        </p:nvSpPr>
+        <p:spPr>
+          <a:xfrm>
+            <a:off x="8584387" y="3611880"/>
+            <a:ext cx="768096" cy="502920"/>
+          </a:xfrm>
+          <a:prstGeom prst="ellipse">
+            <a:avLst/>
+          </a:prstGeom>
+          <a:solidFill>
+            <a:srgbClr val="0E5C8A"/>
+          </a:solidFill>
+          <a:ln w="19050">
+            <a:solidFill>
+              <a:srgbClr val="FFFFFF"/>
+            </a:solidFill>
+            <a:prstDash val="solid"/>
+          </a:ln>
+        </p:spPr>
+      </p:sp>
+      <p:sp>
+        <p:nvSpPr>
+          <p:cNvPr id="34" name="Text 32"/>
+          <p:cNvSpPr/>
+          <p:nvPr/>
+        </p:nvSpPr>
+        <p:spPr>
+          <a:xfrm>
+            <a:off x="8465515" y="3593592"/>
+            <a:ext cx="1005840" cy="502920"/>
+          </a:xfrm>
+          <a:prstGeom prst="rect">
+            <a:avLst/>
+          </a:prstGeom>
+          <a:noFill/>
+          <a:ln/>
+        </p:spPr>
+        <p:txBody>
+          <a:bodyPr wrap="square" rtlCol="0" anchor="ctr"/>
+          <a:lstStyle/>
+          <a:p>
+            <a:pPr algn="ctr" indent="0" marL="0">
+              <a:buNone/>
+            </a:pPr>
+            <a:r>
+              <a:rPr lang="en-US" sz="850" b="1" dirty="0">
+                <a:solidFill>
+                  <a:srgbClr val="FFFFFF"/>
+                </a:solidFill>
+                <a:latin typeface="Malgun Gothic" pitchFamily="34" charset="0"/>
+                <a:ea typeface="Malgun Gothic" pitchFamily="34" charset="-122"/>
+                <a:cs typeface="Malgun Gothic" pitchFamily="34" charset="-120"/>
+              </a:rPr>
+              <a:t>재라벨링 +</a:t>
+            </a:r>
+            <a:endParaRPr lang="en-US" sz="850" dirty="0"/>
+          </a:p>
+          <a:p>
+            <a:pPr algn="ctr" indent="0" marL="0">
+              <a:buNone/>
+            </a:pPr>
+            <a:r>
+              <a:rPr lang="en-US" sz="850" b="1" dirty="0">
+                <a:solidFill>
+                  <a:srgbClr val="FFFFFF"/>
+                </a:solidFill>
+                <a:latin typeface="Malgun Gothic" pitchFamily="34" charset="0"/>
+                <a:ea typeface="Malgun Gothic" pitchFamily="34" charset="-122"/>
+                <a:cs typeface="Malgun Gothic" pitchFamily="34" charset="-120"/>
+              </a:rPr>
+              <a:t>재학습</a:t>
+            </a:r>
+            <a:endParaRPr lang="en-US" sz="850" dirty="0"/>
+          </a:p>
+        </p:txBody>
+      </p:sp>
+      <p:sp>
+        <p:nvSpPr>
+          <p:cNvPr id="35" name="Shape 33"/>
+          <p:cNvSpPr/>
+          <p:nvPr/>
+        </p:nvSpPr>
+        <p:spPr>
+          <a:xfrm>
+            <a:off x="7807147" y="2834640"/>
+            <a:ext cx="768096" cy="502920"/>
+          </a:xfrm>
+          <a:prstGeom prst="ellipse">
+            <a:avLst/>
+          </a:prstGeom>
+          <a:solidFill>
+            <a:srgbClr val="2E7D5B"/>
+          </a:solidFill>
+          <a:ln w="19050">
+            <a:solidFill>
+              <a:srgbClr val="FFFFFF"/>
+            </a:solidFill>
+            <a:prstDash val="solid"/>
+          </a:ln>
+        </p:spPr>
+      </p:sp>
+      <p:sp>
+        <p:nvSpPr>
+          <p:cNvPr id="36" name="Text 34"/>
+          <p:cNvSpPr/>
+          <p:nvPr/>
+        </p:nvSpPr>
+        <p:spPr>
+          <a:xfrm>
+            <a:off x="7688275" y="2816352"/>
+            <a:ext cx="1005840" cy="502920"/>
+          </a:xfrm>
+          <a:prstGeom prst="rect">
+            <a:avLst/>
+          </a:prstGeom>
+          <a:noFill/>
+          <a:ln/>
+        </p:spPr>
+        <p:txBody>
+          <a:bodyPr wrap="square" rtlCol="0" anchor="ctr"/>
+          <a:lstStyle/>
+          <a:p>
+            <a:pPr algn="ctr" indent="0" marL="0">
+              <a:buNone/>
+            </a:pPr>
+            <a:r>
+              <a:rPr lang="en-US" sz="850" b="1" dirty="0">
+                <a:solidFill>
+                  <a:srgbClr val="FFFFFF"/>
+                </a:solidFill>
+                <a:latin typeface="Malgun Gothic" pitchFamily="34" charset="0"/>
+                <a:ea typeface="Malgun Gothic" pitchFamily="34" charset="-122"/>
+                <a:cs typeface="Malgun Gothic" pitchFamily="34" charset="-120"/>
+              </a:rPr>
+              <a:t>신모델</a:t>
+            </a:r>
+            <a:endParaRPr lang="en-US" sz="850" dirty="0"/>
+          </a:p>
+          <a:p>
+            <a:pPr algn="ctr" indent="0" marL="0">
+              <a:buNone/>
+            </a:pPr>
+            <a:r>
+              <a:rPr lang="en-US" sz="850" b="1" dirty="0">
+                <a:solidFill>
+                  <a:srgbClr val="FFFFFF"/>
+                </a:solidFill>
+                <a:latin typeface="Malgun Gothic" pitchFamily="34" charset="0"/>
+                <a:ea typeface="Malgun Gothic" pitchFamily="34" charset="-122"/>
+                <a:cs typeface="Malgun Gothic" pitchFamily="34" charset="-120"/>
+              </a:rPr>
+              <a:t>OTA 배포</a:t>
+            </a:r>
+            <a:endParaRPr lang="en-US" sz="850" dirty="0"/>
+          </a:p>
+        </p:txBody>
+      </p:sp>
+      <p:sp>
+        <p:nvSpPr>
+          <p:cNvPr id="37" name="Text 35"/>
+          <p:cNvSpPr/>
+          <p:nvPr/>
+        </p:nvSpPr>
+        <p:spPr>
+          <a:xfrm>
+            <a:off x="6385255" y="3794760"/>
+            <a:ext cx="5166360" cy="274320"/>
+          </a:xfrm>
+          <a:prstGeom prst="rect">
+            <a:avLst/>
+          </a:prstGeom>
+          <a:noFill/>
+          <a:ln/>
+        </p:spPr>
+        <p:txBody>
+          <a:bodyPr wrap="square" rtlCol="0" anchor="ctr"/>
+          <a:lstStyle/>
+          <a:p>
+            <a:pPr algn="ctr" indent="0" marL="0">
+              <a:buNone/>
+            </a:pPr>
+            <a:r>
+              <a:rPr lang="en-US" sz="1000" b="1" dirty="0">
+                <a:solidFill>
+                  <a:srgbClr val="2E7D5B"/>
+                </a:solidFill>
+                <a:latin typeface="Malgun Gothic" pitchFamily="34" charset="0"/>
+                <a:ea typeface="Malgun Gothic" pitchFamily="34" charset="-122"/>
+                <a:cs typeface="Malgun Gothic" pitchFamily="34" charset="-120"/>
+              </a:rPr>
+              <a:t>운영 비용 — 분기당 ₩6,000만+ (재라벨링 + 컴퓨팅 + 모델 배포)</a:t>
+            </a:r>
+            <a:endParaRPr lang="en-US" sz="1000" dirty="0"/>
+          </a:p>
+        </p:txBody>
+      </p:sp>
+      <p:sp>
+        <p:nvSpPr>
+          <p:cNvPr id="38" name="Shape 36"/>
+          <p:cNvSpPr/>
+          <p:nvPr/>
+        </p:nvSpPr>
+        <p:spPr>
+          <a:xfrm>
+            <a:off x="457200" y="4434840"/>
+            <a:ext cx="11277295" cy="1828800"/>
+          </a:xfrm>
+          <a:prstGeom prst="roundRect">
+            <a:avLst>
+              <a:gd name="adj" fmla="val 7500"/>
+            </a:avLst>
+          </a:prstGeom>
+          <a:solidFill>
+            <a:srgbClr val="F7E8D0"/>
+          </a:solidFill>
+          <a:ln w="15240">
+            <a:solidFill>
+              <a:srgbClr val="C77E1E"/>
+            </a:solidFill>
+            <a:prstDash val="solid"/>
+          </a:ln>
+        </p:spPr>
+      </p:sp>
+      <p:sp>
+        <p:nvSpPr>
+          <p:cNvPr id="39" name="Shape 37"/>
+          <p:cNvSpPr/>
+          <p:nvPr/>
+        </p:nvSpPr>
+        <p:spPr>
+          <a:xfrm>
+            <a:off x="457200" y="4434840"/>
+            <a:ext cx="11277295" cy="457200"/>
+          </a:xfrm>
+          <a:prstGeom prst="rect">
+            <a:avLst/>
+          </a:prstGeom>
+          <a:solidFill>
+            <a:srgbClr val="C77E1E"/>
+          </a:solidFill>
+          <a:ln w="12700">
+            <a:solidFill>
+              <a:srgbClr val="C77E1E"/>
+            </a:solidFill>
+            <a:prstDash val="solid"/>
+          </a:ln>
+        </p:spPr>
+      </p:sp>
+      <p:sp>
+        <p:nvSpPr>
+          <p:cNvPr id="40" name="Text 38"/>
+          <p:cNvSpPr/>
+          <p:nvPr/>
+        </p:nvSpPr>
+        <p:spPr>
+          <a:xfrm>
+            <a:off x="640080" y="4480560"/>
+            <a:ext cx="10911535" cy="365760"/>
+          </a:xfrm>
+          <a:prstGeom prst="rect">
+            <a:avLst/>
+          </a:prstGeom>
+          <a:noFill/>
+          <a:ln/>
+        </p:spPr>
+        <p:txBody>
+          <a:bodyPr wrap="square" rtlCol="0" anchor="ctr"/>
+          <a:lstStyle/>
+          <a:p>
+            <a:pPr indent="0" marL="0">
+              <a:buNone/>
+            </a:pPr>
+            <a:r>
+              <a:rPr lang="en-US" sz="1100" b="1" spc="100" kern="0" dirty="0">
+                <a:solidFill>
+                  <a:srgbClr val="FFFFFF"/>
+                </a:solidFill>
+                <a:latin typeface="Malgun Gothic" pitchFamily="34" charset="0"/>
+                <a:ea typeface="Malgun Gothic" pitchFamily="34" charset="-122"/>
+                <a:cs typeface="Malgun Gothic" pitchFamily="34" charset="-120"/>
+              </a:rPr>
+              <a:t>STEP 3 — 정확도 100%는 물리적으로 불가능합니다 (현실적 기대치 공유)</a:t>
+            </a:r>
+            <a:endParaRPr lang="en-US" sz="1100" dirty="0"/>
+          </a:p>
+        </p:txBody>
+      </p:sp>
+      <p:sp>
+        <p:nvSpPr>
+          <p:cNvPr id="41" name="Text 39"/>
+          <p:cNvSpPr/>
+          <p:nvPr/>
+        </p:nvSpPr>
+        <p:spPr>
+          <a:xfrm>
+            <a:off x="640080" y="4983480"/>
+            <a:ext cx="5486400" cy="274320"/>
+          </a:xfrm>
+          <a:prstGeom prst="rect">
+            <a:avLst/>
+          </a:prstGeom>
+          <a:noFill/>
+          <a:ln/>
+        </p:spPr>
+        <p:txBody>
+          <a:bodyPr wrap="square" rtlCol="0" anchor="ctr"/>
+          <a:lstStyle/>
+          <a:p>
+            <a:pPr indent="0" marL="0">
+              <a:buNone/>
+            </a:pPr>
+            <a:r>
+              <a:rPr lang="en-US" sz="1100" b="1" dirty="0">
+                <a:solidFill>
+                  <a:srgbClr val="1A2B3C"/>
+                </a:solidFill>
+                <a:latin typeface="Malgun Gothic" pitchFamily="34" charset="0"/>
+                <a:ea typeface="Malgun Gothic" pitchFamily="34" charset="-122"/>
+                <a:cs typeface="Malgun Gothic" pitchFamily="34" charset="-120"/>
+              </a:rPr>
+              <a:t>절대 통제할 수 없는 5가지 변수</a:t>
+            </a:r>
+            <a:endParaRPr lang="en-US" sz="1100" dirty="0"/>
+          </a:p>
+        </p:txBody>
+      </p:sp>
+      <p:sp>
+        <p:nvSpPr>
+          <p:cNvPr id="42" name="Text 40"/>
+          <p:cNvSpPr/>
+          <p:nvPr/>
+        </p:nvSpPr>
+        <p:spPr>
+          <a:xfrm>
+            <a:off x="777240" y="5303520"/>
+            <a:ext cx="5303520" cy="182880"/>
+          </a:xfrm>
+          <a:prstGeom prst="rect">
+            <a:avLst/>
+          </a:prstGeom>
+          <a:noFill/>
+          <a:ln/>
+        </p:spPr>
+        <p:txBody>
+          <a:bodyPr wrap="square" rtlCol="0" anchor="ctr"/>
+          <a:lstStyle/>
+          <a:p>
+            <a:pPr indent="0" marL="0">
+              <a:buNone/>
+            </a:pPr>
+            <a:r>
+              <a:rPr lang="en-US" sz="1000" dirty="0">
+                <a:solidFill>
+                  <a:srgbClr val="1A2B3C"/>
+                </a:solidFill>
+                <a:latin typeface="Malgun Gothic" pitchFamily="34" charset="0"/>
+                <a:ea typeface="Malgun Gothic" pitchFamily="34" charset="-122"/>
+                <a:cs typeface="Malgun Gothic" pitchFamily="34" charset="-120"/>
+              </a:rPr>
+              <a:t>📷  카메라 센서 편차 (기종마다 색감 다름)</a:t>
+            </a:r>
+            <a:endParaRPr lang="en-US" sz="1000" dirty="0"/>
+          </a:p>
+        </p:txBody>
+      </p:sp>
+      <p:sp>
+        <p:nvSpPr>
+          <p:cNvPr id="43" name="Text 41"/>
+          <p:cNvSpPr/>
+          <p:nvPr/>
+        </p:nvSpPr>
+        <p:spPr>
+          <a:xfrm>
+            <a:off x="777240" y="5468112"/>
+            <a:ext cx="5303520" cy="182880"/>
+          </a:xfrm>
+          <a:prstGeom prst="rect">
+            <a:avLst/>
+          </a:prstGeom>
+          <a:noFill/>
+          <a:ln/>
+        </p:spPr>
+        <p:txBody>
+          <a:bodyPr wrap="square" rtlCol="0" anchor="ctr"/>
+          <a:lstStyle/>
+          <a:p>
+            <a:pPr indent="0" marL="0">
+              <a:buNone/>
+            </a:pPr>
+            <a:r>
+              <a:rPr lang="en-US" sz="1000" dirty="0">
+                <a:solidFill>
+                  <a:srgbClr val="1A2B3C"/>
+                </a:solidFill>
+                <a:latin typeface="Malgun Gothic" pitchFamily="34" charset="0"/>
+                <a:ea typeface="Malgun Gothic" pitchFamily="34" charset="-122"/>
+                <a:cs typeface="Malgun Gothic" pitchFamily="34" charset="-120"/>
+              </a:rPr>
+              <a:t>💡  조명 환경 (LED·형광등·자연광·그늘)</a:t>
+            </a:r>
+            <a:endParaRPr lang="en-US" sz="1000" dirty="0"/>
+          </a:p>
+        </p:txBody>
+      </p:sp>
+      <p:sp>
+        <p:nvSpPr>
+          <p:cNvPr id="44" name="Text 42"/>
+          <p:cNvSpPr/>
+          <p:nvPr/>
+        </p:nvSpPr>
+        <p:spPr>
+          <a:xfrm>
+            <a:off x="777240" y="5632704"/>
+            <a:ext cx="5303520" cy="182880"/>
+          </a:xfrm>
+          <a:prstGeom prst="rect">
+            <a:avLst/>
+          </a:prstGeom>
+          <a:noFill/>
+          <a:ln/>
+        </p:spPr>
+        <p:txBody>
+          <a:bodyPr wrap="square" rtlCol="0" anchor="ctr"/>
+          <a:lstStyle/>
+          <a:p>
+            <a:pPr indent="0" marL="0">
+              <a:buNone/>
+            </a:pPr>
+            <a:r>
+              <a:rPr lang="en-US" sz="1000" dirty="0">
+                <a:solidFill>
+                  <a:srgbClr val="1A2B3C"/>
+                </a:solidFill>
+                <a:latin typeface="Malgun Gothic" pitchFamily="34" charset="0"/>
+                <a:ea typeface="Malgun Gothic" pitchFamily="34" charset="-122"/>
+                <a:cs typeface="Malgun Gothic" pitchFamily="34" charset="-120"/>
+              </a:rPr>
+              <a:t>📦  포장재 반사·결로·비닐 광택</a:t>
+            </a:r>
+            <a:endParaRPr lang="en-US" sz="1000" dirty="0"/>
+          </a:p>
+        </p:txBody>
+      </p:sp>
+      <p:sp>
+        <p:nvSpPr>
+          <p:cNvPr id="45" name="Text 43"/>
+          <p:cNvSpPr/>
+          <p:nvPr/>
+        </p:nvSpPr>
+        <p:spPr>
+          <a:xfrm>
+            <a:off x="777240" y="5797296"/>
+            <a:ext cx="5303520" cy="182880"/>
+          </a:xfrm>
+          <a:prstGeom prst="rect">
+            <a:avLst/>
+          </a:prstGeom>
+          <a:noFill/>
+          <a:ln/>
+        </p:spPr>
+        <p:txBody>
+          <a:bodyPr wrap="square" rtlCol="0" anchor="ctr"/>
+          <a:lstStyle/>
+          <a:p>
+            <a:pPr indent="0" marL="0">
+              <a:buNone/>
+            </a:pPr>
+            <a:r>
+              <a:rPr lang="en-US" sz="1000" dirty="0">
+                <a:solidFill>
+                  <a:srgbClr val="1A2B3C"/>
+                </a:solidFill>
+                <a:latin typeface="Malgun Gothic" pitchFamily="34" charset="0"/>
+                <a:ea typeface="Malgun Gothic" pitchFamily="34" charset="-122"/>
+                <a:cs typeface="Malgun Gothic" pitchFamily="34" charset="-120"/>
+              </a:rPr>
+              <a:t>🧪  칩 자체의 제조 편차 · 온도 이력</a:t>
+            </a:r>
+            <a:endParaRPr lang="en-US" sz="1000" dirty="0"/>
+          </a:p>
+        </p:txBody>
+      </p:sp>
+      <p:sp>
+        <p:nvSpPr>
+          <p:cNvPr id="46" name="Text 44"/>
+          <p:cNvSpPr/>
+          <p:nvPr/>
+        </p:nvSpPr>
+        <p:spPr>
+          <a:xfrm>
+            <a:off x="777240" y="5961888"/>
+            <a:ext cx="5303520" cy="182880"/>
+          </a:xfrm>
+          <a:prstGeom prst="rect">
+            <a:avLst/>
+          </a:prstGeom>
+          <a:noFill/>
+          <a:ln/>
+        </p:spPr>
+        <p:txBody>
+          <a:bodyPr wrap="square" rtlCol="0" anchor="ctr"/>
+          <a:lstStyle/>
+          <a:p>
+            <a:pPr indent="0" marL="0">
+              <a:buNone/>
+            </a:pPr>
+            <a:r>
+              <a:rPr lang="en-US" sz="1000" dirty="0">
+                <a:solidFill>
+                  <a:srgbClr val="1A2B3C"/>
+                </a:solidFill>
+                <a:latin typeface="Malgun Gothic" pitchFamily="34" charset="0"/>
+                <a:ea typeface="Malgun Gothic" pitchFamily="34" charset="-122"/>
+                <a:cs typeface="Malgun Gothic" pitchFamily="34" charset="-120"/>
+              </a:rPr>
+              <a:t>👆  사용자 촬영 각도 · 손가락 가림</a:t>
+            </a:r>
+            <a:endParaRPr lang="en-US" sz="1000" dirty="0"/>
+          </a:p>
+        </p:txBody>
+      </p:sp>
+      <p:sp>
+        <p:nvSpPr>
+          <p:cNvPr id="47" name="Text 45"/>
+          <p:cNvSpPr/>
+          <p:nvPr/>
+        </p:nvSpPr>
+        <p:spPr>
+          <a:xfrm>
+            <a:off x="6400800" y="4983480"/>
+            <a:ext cx="5303520" cy="274320"/>
+          </a:xfrm>
+          <a:prstGeom prst="rect">
+            <a:avLst/>
+          </a:prstGeom>
+          <a:noFill/>
+          <a:ln/>
+        </p:spPr>
+        <p:txBody>
+          <a:bodyPr wrap="square" rtlCol="0" anchor="ctr"/>
+          <a:lstStyle/>
+          <a:p>
+            <a:pPr indent="0" marL="0">
+              <a:buNone/>
+            </a:pPr>
+            <a:r>
+              <a:rPr lang="en-US" sz="1100" b="1" dirty="0">
+                <a:solidFill>
+                  <a:srgbClr val="1A2B3C"/>
+                </a:solidFill>
+                <a:latin typeface="Malgun Gothic" pitchFamily="34" charset="0"/>
+                <a:ea typeface="Malgun Gothic" pitchFamily="34" charset="-122"/>
+                <a:cs typeface="Malgun Gothic" pitchFamily="34" charset="-120"/>
+              </a:rPr>
+              <a:t>실현 가능한 목표 정확도</a:t>
+            </a:r>
+            <a:endParaRPr lang="en-US" sz="1100" dirty="0"/>
+          </a:p>
+        </p:txBody>
+      </p:sp>
+      <p:sp>
+        <p:nvSpPr>
+          <p:cNvPr id="48" name="Shape 46"/>
+          <p:cNvSpPr/>
+          <p:nvPr/>
+        </p:nvSpPr>
+        <p:spPr>
+          <a:xfrm>
+            <a:off x="6400800" y="5303520"/>
+            <a:ext cx="2468880" cy="548640"/>
+          </a:xfrm>
+          <a:prstGeom prst="rect">
+            <a:avLst/>
+          </a:prstGeom>
+          <a:solidFill>
+            <a:srgbClr val="FFFFFF"/>
+          </a:solidFill>
+          <a:ln w="19050">
+            <a:solidFill>
+              <a:srgbClr val="C77E1E"/>
+            </a:solidFill>
+            <a:prstDash val="solid"/>
+          </a:ln>
+        </p:spPr>
+      </p:sp>
+      <p:sp>
+        <p:nvSpPr>
+          <p:cNvPr id="49" name="Text 47"/>
+          <p:cNvSpPr/>
+          <p:nvPr/>
+        </p:nvSpPr>
+        <p:spPr>
+          <a:xfrm>
+            <a:off x="6446520" y="5349240"/>
+            <a:ext cx="914400" cy="457200"/>
+          </a:xfrm>
+          <a:prstGeom prst="rect">
+            <a:avLst/>
+          </a:prstGeom>
+          <a:noFill/>
+          <a:ln/>
+        </p:spPr>
+        <p:txBody>
+          <a:bodyPr wrap="square" rtlCol="0" anchor="ctr"/>
+          <a:lstStyle/>
+          <a:p>
+            <a:pPr algn="ctr" indent="0" marL="0">
+              <a:buNone/>
+            </a:pPr>
+            <a:r>
+              <a:rPr lang="en-US" sz="1800" b="1" dirty="0">
+                <a:solidFill>
+                  <a:srgbClr val="C77E1E"/>
+                </a:solidFill>
+                <a:latin typeface="Malgun Gothic" pitchFamily="34" charset="0"/>
+                <a:ea typeface="Malgun Gothic" pitchFamily="34" charset="-122"/>
+                <a:cs typeface="Malgun Gothic" pitchFamily="34" charset="-120"/>
+              </a:rPr>
+              <a:t>≥ 95%</a:t>
+            </a:r>
+            <a:endParaRPr lang="en-US" sz="1800" dirty="0"/>
+          </a:p>
+        </p:txBody>
+      </p:sp>
+      <p:sp>
+        <p:nvSpPr>
+          <p:cNvPr id="50" name="Text 48"/>
+          <p:cNvSpPr/>
+          <p:nvPr/>
+        </p:nvSpPr>
+        <p:spPr>
+          <a:xfrm>
+            <a:off x="7315200" y="5349240"/>
+            <a:ext cx="1463040" cy="457200"/>
+          </a:xfrm>
+          <a:prstGeom prst="rect">
+            <a:avLst/>
+          </a:prstGeom>
+          <a:noFill/>
+          <a:ln/>
+        </p:spPr>
+        <p:txBody>
+          <a:bodyPr wrap="square" rtlCol="0" anchor="ctr"/>
+          <a:lstStyle/>
+          <a:p>
+            <a:pPr indent="0" marL="0">
+              <a:buNone/>
+            </a:pPr>
+            <a:r>
+              <a:rPr lang="en-US" sz="950" dirty="0">
+                <a:solidFill>
+                  <a:srgbClr val="1A2B3C"/>
+                </a:solidFill>
+                <a:latin typeface="Malgun Gothic" pitchFamily="34" charset="0"/>
+                <a:ea typeface="Malgun Gothic" pitchFamily="34" charset="-122"/>
+                <a:cs typeface="Malgun Gothic" pitchFamily="34" charset="-120"/>
+              </a:rPr>
+              <a:t>Beta 출시 시점</a:t>
+            </a:r>
+            <a:endParaRPr lang="en-US" sz="950" dirty="0"/>
+          </a:p>
+        </p:txBody>
+      </p:sp>
+      <p:sp>
+        <p:nvSpPr>
+          <p:cNvPr id="51" name="Shape 49"/>
+          <p:cNvSpPr/>
+          <p:nvPr/>
+        </p:nvSpPr>
+        <p:spPr>
+          <a:xfrm>
+            <a:off x="9052560" y="5303520"/>
+            <a:ext cx="2468880" cy="548640"/>
+          </a:xfrm>
+          <a:prstGeom prst="rect">
+            <a:avLst/>
+          </a:prstGeom>
+          <a:solidFill>
+            <a:srgbClr val="FFFFFF"/>
+          </a:solidFill>
+          <a:ln w="19050">
+            <a:solidFill>
+              <a:srgbClr val="2E7D5B"/>
+            </a:solidFill>
+            <a:prstDash val="solid"/>
+          </a:ln>
+        </p:spPr>
+      </p:sp>
+      <p:sp>
+        <p:nvSpPr>
+          <p:cNvPr id="52" name="Text 50"/>
+          <p:cNvSpPr/>
+          <p:nvPr/>
+        </p:nvSpPr>
+        <p:spPr>
+          <a:xfrm>
+            <a:off x="9098280" y="5349240"/>
+            <a:ext cx="914400" cy="457200"/>
+          </a:xfrm>
+          <a:prstGeom prst="rect">
+            <a:avLst/>
+          </a:prstGeom>
+          <a:noFill/>
+          <a:ln/>
+        </p:spPr>
+        <p:txBody>
+          <a:bodyPr wrap="square" rtlCol="0" anchor="ctr"/>
+          <a:lstStyle/>
+          <a:p>
+            <a:pPr algn="ctr" indent="0" marL="0">
+              <a:buNone/>
+            </a:pPr>
+            <a:r>
+              <a:rPr lang="en-US" sz="1800" b="1" dirty="0">
+                <a:solidFill>
+                  <a:srgbClr val="2E7D5B"/>
+                </a:solidFill>
+                <a:latin typeface="Malgun Gothic" pitchFamily="34" charset="0"/>
+                <a:ea typeface="Malgun Gothic" pitchFamily="34" charset="-122"/>
+                <a:cs typeface="Malgun Gothic" pitchFamily="34" charset="-120"/>
+              </a:rPr>
+              <a:t>≥ 98%</a:t>
+            </a:r>
+            <a:endParaRPr lang="en-US" sz="1800" dirty="0"/>
+          </a:p>
+        </p:txBody>
+      </p:sp>
+      <p:sp>
+        <p:nvSpPr>
+          <p:cNvPr id="53" name="Text 51"/>
+          <p:cNvSpPr/>
+          <p:nvPr/>
+        </p:nvSpPr>
+        <p:spPr>
+          <a:xfrm>
+            <a:off x="9966960" y="5349240"/>
+            <a:ext cx="1463040" cy="457200"/>
+          </a:xfrm>
+          <a:prstGeom prst="rect">
+            <a:avLst/>
+          </a:prstGeom>
+          <a:noFill/>
+          <a:ln/>
+        </p:spPr>
+        <p:txBody>
+          <a:bodyPr wrap="square" rtlCol="0" anchor="ctr"/>
+          <a:lstStyle/>
+          <a:p>
+            <a:pPr indent="0" marL="0">
+              <a:buNone/>
+            </a:pPr>
+            <a:r>
+              <a:rPr lang="en-US" sz="950" dirty="0">
+                <a:solidFill>
+                  <a:srgbClr val="1A2B3C"/>
+                </a:solidFill>
+                <a:latin typeface="Malgun Gothic" pitchFamily="34" charset="0"/>
+                <a:ea typeface="Malgun Gothic" pitchFamily="34" charset="-122"/>
+                <a:cs typeface="Malgun Gothic" pitchFamily="34" charset="-120"/>
+              </a:rPr>
+              <a:t>1년 운영 후 (Active Learning)</a:t>
+            </a:r>
+            <a:endParaRPr lang="en-US" sz="950" dirty="0"/>
+          </a:p>
+        </p:txBody>
+      </p:sp>
+      <p:sp>
+        <p:nvSpPr>
+          <p:cNvPr id="54" name="Text 52"/>
+          <p:cNvSpPr/>
+          <p:nvPr/>
+        </p:nvSpPr>
+        <p:spPr>
+          <a:xfrm>
+            <a:off x="6400800" y="5916168"/>
+            <a:ext cx="5303520" cy="292608"/>
+          </a:xfrm>
+          <a:prstGeom prst="rect">
+            <a:avLst/>
+          </a:prstGeom>
+          <a:noFill/>
+          <a:ln/>
+        </p:spPr>
+        <p:txBody>
+          <a:bodyPr wrap="square" rtlCol="0" anchor="ctr"/>
+          <a:lstStyle/>
+          <a:p>
+            <a:pPr indent="0" marL="0">
+              <a:buNone/>
+            </a:pPr>
+            <a:r>
+              <a:rPr lang="en-US" sz="900" i="1" dirty="0">
+                <a:solidFill>
+                  <a:srgbClr val="6B7785"/>
+                </a:solidFill>
+                <a:latin typeface="Malgun Gothic" pitchFamily="34" charset="0"/>
+                <a:ea typeface="Malgun Gothic" pitchFamily="34" charset="-122"/>
+                <a:cs typeface="Malgun Gothic" pitchFamily="34" charset="-120"/>
+              </a:rPr>
+              <a:t>100% 보장형 의료/안전 인증 도구가 아닌 "보조 판정 도구"로 포지셔닝 — 식약처 식품 보조표시 가이드라인 준용</a:t>
+            </a:r>
+            <a:endParaRPr lang="en-US" sz="900" dirty="0"/>
           </a:p>
         </p:txBody>
       </p:sp>

</xml_diff>

<commit_message>
Add a glossary of technical terms and abbreviations to the presentation
Adds a new 6th slide to the presentation containing an English abbreviation glossary, and updates the total page count metadata.

Replit-Commit-Author: Agent
Replit-Commit-Session-Id: 6ede0d58-6595-48bd-b72a-9e64018177cd
Replit-Commit-Checkpoint-Type: full_checkpoint
Replit-Commit-Event-Id: 71707a83-12c2-47ca-8edb-ec1dc33a05ac
Replit-Commit-Screenshot-Url: https://storage.googleapis.com/screenshot-production-us-central1/1ae31300-7c48-4a8a-bbb7-f1f0ab58e9d3/6ede0d58-6595-48bd-b72a-9e64018177cd/NO9t4AA
Replit-Helium-Checkpoint-Created: true
</commit_message>
<xml_diff>
--- a/exports/lotusbio_tti_demo.pptx
+++ b/exports/lotusbio_tti_demo.pptx
@@ -10,9 +10,10 @@
     <p:sldId id="258" r:id="rId4"/>
     <p:sldId id="259" r:id="rId5"/>
     <p:sldId id="260" r:id="rId6"/>
+    <p:sldId id="261" r:id="rId7"/>
   </p:sldIdLst>
   <p:notesMasterIdLst>
-    <p:notesMasterId r:id="rId7"/>
+    <p:notesMasterId r:id="rId8"/>
   </p:notesMasterIdLst>
   <p:sldSz cx="12192000" cy="6858000"/>
   <p:notesSz cx="6858000" cy="12192000"/>
@@ -882,6 +883,94 @@
             <a:fld id="{F7021451-1387-4CA6-816F-3879F97B5CBC}" type="slidenum">
               <a:rPr lang="en-US"/>
               <a:t>5</a:t>
+            </a:fld>
+            <a:endParaRPr lang="en-US"/>
+          </a:p>
+        </p:txBody>
+      </p:sp>
+    </p:spTree>
+    <p:extLst>
+      <p:ext uri="{BB962C8B-B14F-4D97-AF65-F5344CB8AC3E}">
+        <p14:creationId xmlns:p14="http://schemas.microsoft.com/office/powerpoint/2010/main" val="1024086991"/>
+      </p:ext>
+    </p:extLst>
+  </p:cSld>
+  <p:clrMapOvr>
+    <a:masterClrMapping/>
+  </p:clrMapOvr>
+</p:notes>
+</file>
+
+<file path=ppt/notesSlides/notesSlide6.xml><?xml version="1.0" encoding="utf-8"?>
+<p:notes xmlns:a="http://schemas.openxmlformats.org/drawingml/2006/main" xmlns:r="http://schemas.openxmlformats.org/officeDocument/2006/relationships" xmlns:p="http://schemas.openxmlformats.org/presentationml/2006/main">
+  <p:cSld>
+    <p:spTree>
+      <p:nvGrpSpPr>
+        <p:cNvPr id="1" name=""/>
+        <p:cNvGrpSpPr/>
+        <p:nvPr/>
+      </p:nvGrpSpPr>
+      <p:grpSpPr>
+        <a:xfrm>
+          <a:off x="0" y="0"/>
+          <a:ext cx="0" cy="0"/>
+          <a:chOff x="0" y="0"/>
+          <a:chExt cx="0" cy="0"/>
+        </a:xfrm>
+      </p:grpSpPr>
+      <p:sp>
+        <p:nvSpPr>
+          <p:cNvPr id="2" name="Slide Image Placeholder 1"/>
+          <p:cNvSpPr>
+            <a:spLocks noGrp="1" noRot="1" noChangeAspect="1"/>
+          </p:cNvSpPr>
+          <p:nvPr>
+            <p:ph type="sldImg"/>
+          </p:nvPr>
+        </p:nvSpPr>
+        <p:spPr/>
+      </p:sp>
+      <p:sp>
+        <p:nvSpPr>
+          <p:cNvPr id="3" name="Notes Placeholder 2"/>
+          <p:cNvSpPr>
+            <a:spLocks noGrp="1"/>
+          </p:cNvSpPr>
+          <p:nvPr>
+            <p:ph type="body" idx="1"/>
+          </p:nvPr>
+        </p:nvSpPr>
+        <p:spPr/>
+        <p:txBody>
+          <a:bodyPr/>
+          <a:lstStyle/>
+          <a:p>
+            <a:r>
+              <a:rPr lang="en-US" dirty="0"/>
+              <a:t/>
+            </a:r>
+            <a:endParaRPr lang="en-US" dirty="0"/>
+          </a:p>
+        </p:txBody>
+      </p:sp>
+      <p:sp>
+        <p:nvSpPr>
+          <p:cNvPr id="4" name="Slide Number Placeholder 3"/>
+          <p:cNvSpPr>
+            <a:spLocks noGrp="1"/>
+          </p:cNvSpPr>
+          <p:nvPr>
+            <p:ph type="sldNum" sz="quarter" idx="10"/>
+          </p:nvPr>
+        </p:nvSpPr>
+        <p:spPr/>
+        <p:txBody>
+          <a:bodyPr/>
+          <a:lstStyle/>
+          <a:p>
+            <a:fld id="{F7021451-1387-4CA6-816F-3879F97B5CBC}" type="slidenum">
+              <a:rPr lang="en-US"/>
+              <a:t>6</a:t>
             </a:fld>
             <a:endParaRPr lang="en-US"/>
           </a:p>
@@ -2484,7 +2573,7 @@
                 <a:ea typeface="Malgun Gothic" pitchFamily="34" charset="-122"/>
                 <a:cs typeface="Malgun Gothic" pitchFamily="34" charset="-120"/>
               </a:rPr>
-              <a:t>1 / 5</a:t>
+              <a:t>1 / 6</a:t>
             </a:r>
             <a:endParaRPr lang="en-US" sz="900" dirty="0"/>
           </a:p>
@@ -2658,7 +2747,7 @@
                 <a:ea typeface="Malgun Gothic" pitchFamily="34" charset="-122"/>
                 <a:cs typeface="Malgun Gothic" pitchFamily="34" charset="-120"/>
               </a:rPr>
-              <a:t>2 / 5</a:t>
+              <a:t>2 / 6</a:t>
             </a:r>
             <a:endParaRPr lang="en-US" sz="900" dirty="0"/>
           </a:p>
@@ -4494,7 +4583,7 @@
                 <a:ea typeface="Malgun Gothic" pitchFamily="34" charset="-122"/>
                 <a:cs typeface="Malgun Gothic" pitchFamily="34" charset="-120"/>
               </a:rPr>
-              <a:t>3 / 5</a:t>
+              <a:t>3 / 6</a:t>
             </a:r>
             <a:endParaRPr lang="en-US" sz="900" dirty="0"/>
           </a:p>
@@ -6729,7 +6818,7 @@
                 <a:ea typeface="Malgun Gothic" pitchFamily="34" charset="-122"/>
                 <a:cs typeface="Malgun Gothic" pitchFamily="34" charset="-120"/>
               </a:rPr>
-              <a:t>4 / 5</a:t>
+              <a:t>4 / 6</a:t>
             </a:r>
             <a:endParaRPr lang="en-US" sz="900" dirty="0"/>
           </a:p>
@@ -9106,7 +9195,7 @@
                 <a:ea typeface="Malgun Gothic" pitchFamily="34" charset="-122"/>
                 <a:cs typeface="Malgun Gothic" pitchFamily="34" charset="-120"/>
               </a:rPr>
-              <a:t>5 / 5</a:t>
+              <a:t>5 / 6</a:t>
             </a:r>
             <a:endParaRPr lang="en-US" sz="900" dirty="0"/>
           </a:p>
@@ -10922,6 +11011,2207 @@
                 <a:cs typeface="Malgun Gothic" pitchFamily="34" charset="-120"/>
               </a:rPr>
               <a:t>100% 보장형 의료/안전 인증 도구가 아닌 "보조 판정 도구"로 포지셔닝 — 식약처 식품 보조표시 가이드라인 준용</a:t>
+            </a:r>
+            <a:endParaRPr lang="en-US" sz="900" dirty="0"/>
+          </a:p>
+        </p:txBody>
+      </p:sp>
+    </p:spTree>
+  </p:cSld>
+  <p:clrMapOvr>
+    <a:masterClrMapping/>
+  </p:clrMapOvr>
+</p:sld>
+</file>
+
+<file path=ppt/slides/slide6.xml><?xml version="1.0" encoding="utf-8"?>
+<p:sld xmlns:a="http://schemas.openxmlformats.org/drawingml/2006/main" xmlns:r="http://schemas.openxmlformats.org/officeDocument/2006/relationships" xmlns:p="http://schemas.openxmlformats.org/presentationml/2006/main">
+  <p:cSld name="Slide 6">
+    <p:bg>
+      <p:bgPr>
+        <a:solidFill>
+          <a:srgbClr val="FFFFFF"/>
+        </a:solidFill>
+      </p:bgPr>
+    </p:bg>
+    <p:spTree>
+      <p:nvGrpSpPr>
+        <p:cNvPr id="1" name=""/>
+        <p:cNvGrpSpPr/>
+        <p:nvPr/>
+      </p:nvGrpSpPr>
+      <p:grpSpPr>
+        <a:xfrm>
+          <a:off x="0" y="0"/>
+          <a:ext cx="0" cy="0"/>
+          <a:chOff x="0" y="0"/>
+          <a:chExt cx="0" cy="0"/>
+        </a:xfrm>
+      </p:grpSpPr>
+      <p:sp>
+        <p:nvSpPr>
+          <p:cNvPr id="2" name="Shape 0"/>
+          <p:cNvSpPr/>
+          <p:nvPr/>
+        </p:nvSpPr>
+        <p:spPr>
+          <a:xfrm>
+            <a:off x="0" y="0"/>
+            <a:ext cx="12191695" cy="45720"/>
+          </a:xfrm>
+          <a:prstGeom prst="rect">
+            <a:avLst/>
+          </a:prstGeom>
+          <a:solidFill>
+            <a:srgbClr val="0E5C8A"/>
+          </a:solidFill>
+          <a:ln w="12700">
+            <a:solidFill>
+              <a:srgbClr val="0E5C8A"/>
+            </a:solidFill>
+            <a:prstDash val="solid"/>
+          </a:ln>
+        </p:spPr>
+      </p:sp>
+      <p:sp>
+        <p:nvSpPr>
+          <p:cNvPr id="3" name="Text 1"/>
+          <p:cNvSpPr/>
+          <p:nvPr/>
+        </p:nvSpPr>
+        <p:spPr>
+          <a:xfrm>
+            <a:off x="365760" y="164592"/>
+            <a:ext cx="3657600" cy="274320"/>
+          </a:xfrm>
+          <a:prstGeom prst="rect">
+            <a:avLst/>
+          </a:prstGeom>
+          <a:noFill/>
+          <a:ln/>
+        </p:spPr>
+        <p:txBody>
+          <a:bodyPr wrap="square" rtlCol="0" anchor="ctr"/>
+          <a:lstStyle/>
+          <a:p>
+            <a:pPr indent="0" marL="0">
+              <a:buNone/>
+            </a:pPr>
+            <a:r>
+              <a:rPr lang="en-US" sz="1000" dirty="0">
+                <a:solidFill>
+                  <a:srgbClr val="6B7785"/>
+                </a:solidFill>
+                <a:latin typeface="Malgun Gothic" pitchFamily="34" charset="0"/>
+                <a:ea typeface="Malgun Gothic" pitchFamily="34" charset="-122"/>
+                <a:cs typeface="Malgun Gothic" pitchFamily="34" charset="-120"/>
+              </a:rPr>
+              <a:t>Lotusbio · TTI AI Scanner</a:t>
+            </a:r>
+            <a:endParaRPr lang="en-US" sz="1000" dirty="0"/>
+          </a:p>
+        </p:txBody>
+      </p:sp>
+      <p:sp>
+        <p:nvSpPr>
+          <p:cNvPr id="4" name="Text 2"/>
+          <p:cNvSpPr/>
+          <p:nvPr/>
+        </p:nvSpPr>
+        <p:spPr>
+          <a:xfrm>
+            <a:off x="8991295" y="164592"/>
+            <a:ext cx="2834640" cy="274320"/>
+          </a:xfrm>
+          <a:prstGeom prst="rect">
+            <a:avLst/>
+          </a:prstGeom>
+          <a:noFill/>
+          <a:ln/>
+        </p:spPr>
+        <p:txBody>
+          <a:bodyPr wrap="square" rtlCol="0" anchor="ctr"/>
+          <a:lstStyle/>
+          <a:p>
+            <a:pPr algn="r" indent="0" marL="0">
+              <a:buNone/>
+            </a:pPr>
+            <a:r>
+              <a:rPr lang="en-US" sz="1000" spc="200" kern="0" dirty="0">
+                <a:solidFill>
+                  <a:srgbClr val="6B7785"/>
+                </a:solidFill>
+                <a:latin typeface="Malgun Gothic" pitchFamily="34" charset="0"/>
+                <a:ea typeface="Malgun Gothic" pitchFamily="34" charset="-122"/>
+                <a:cs typeface="Malgun Gothic" pitchFamily="34" charset="-120"/>
+              </a:rPr>
+              <a:t>INVESTOR DECK · 2026</a:t>
+            </a:r>
+            <a:endParaRPr lang="en-US" sz="1000" dirty="0"/>
+          </a:p>
+        </p:txBody>
+      </p:sp>
+      <p:sp>
+        <p:nvSpPr>
+          <p:cNvPr id="5" name="Text 3"/>
+          <p:cNvSpPr/>
+          <p:nvPr/>
+        </p:nvSpPr>
+        <p:spPr>
+          <a:xfrm>
+            <a:off x="11277295" y="6492240"/>
+            <a:ext cx="548640" cy="274320"/>
+          </a:xfrm>
+          <a:prstGeom prst="rect">
+            <a:avLst/>
+          </a:prstGeom>
+          <a:noFill/>
+          <a:ln/>
+        </p:spPr>
+        <p:txBody>
+          <a:bodyPr wrap="square" rtlCol="0" anchor="ctr"/>
+          <a:lstStyle/>
+          <a:p>
+            <a:pPr algn="r" indent="0" marL="0">
+              <a:buNone/>
+            </a:pPr>
+            <a:r>
+              <a:rPr lang="en-US" sz="900" dirty="0">
+                <a:solidFill>
+                  <a:srgbClr val="6B7785"/>
+                </a:solidFill>
+                <a:latin typeface="Malgun Gothic" pitchFamily="34" charset="0"/>
+                <a:ea typeface="Malgun Gothic" pitchFamily="34" charset="-122"/>
+                <a:cs typeface="Malgun Gothic" pitchFamily="34" charset="-120"/>
+              </a:rPr>
+              <a:t>6 / 6</a:t>
+            </a:r>
+            <a:endParaRPr lang="en-US" sz="900" dirty="0"/>
+          </a:p>
+        </p:txBody>
+      </p:sp>
+      <p:sp>
+        <p:nvSpPr>
+          <p:cNvPr id="6" name="Text 4"/>
+          <p:cNvSpPr/>
+          <p:nvPr/>
+        </p:nvSpPr>
+        <p:spPr>
+          <a:xfrm>
+            <a:off x="457200" y="502920"/>
+            <a:ext cx="11277295" cy="548640"/>
+          </a:xfrm>
+          <a:prstGeom prst="rect">
+            <a:avLst/>
+          </a:prstGeom>
+          <a:noFill/>
+          <a:ln/>
+        </p:spPr>
+        <p:txBody>
+          <a:bodyPr wrap="square" rtlCol="0" anchor="ctr"/>
+          <a:lstStyle/>
+          <a:p>
+            <a:pPr indent="0" marL="0">
+              <a:buNone/>
+            </a:pPr>
+            <a:r>
+              <a:rPr lang="en-US" sz="2800" b="1" dirty="0">
+                <a:solidFill>
+                  <a:srgbClr val="1A2B3C"/>
+                </a:solidFill>
+                <a:latin typeface="Malgun Gothic" pitchFamily="34" charset="0"/>
+                <a:ea typeface="Malgun Gothic" pitchFamily="34" charset="-122"/>
+                <a:cs typeface="Malgun Gothic" pitchFamily="34" charset="-120"/>
+              </a:rPr>
+              <a:t>용어 · 약어 설명</a:t>
+            </a:r>
+            <a:endParaRPr lang="en-US" sz="2800" dirty="0"/>
+          </a:p>
+        </p:txBody>
+      </p:sp>
+      <p:sp>
+        <p:nvSpPr>
+          <p:cNvPr id="7" name="Text 5"/>
+          <p:cNvSpPr/>
+          <p:nvPr/>
+        </p:nvSpPr>
+        <p:spPr>
+          <a:xfrm>
+            <a:off x="457200" y="1051560"/>
+            <a:ext cx="11277295" cy="320040"/>
+          </a:xfrm>
+          <a:prstGeom prst="rect">
+            <a:avLst/>
+          </a:prstGeom>
+          <a:noFill/>
+          <a:ln/>
+        </p:spPr>
+        <p:txBody>
+          <a:bodyPr wrap="square" rtlCol="0" anchor="ctr"/>
+          <a:lstStyle/>
+          <a:p>
+            <a:pPr indent="0" marL="0">
+              <a:buNone/>
+            </a:pPr>
+            <a:r>
+              <a:rPr lang="en-US" sz="1300" dirty="0">
+                <a:solidFill>
+                  <a:srgbClr val="6B7785"/>
+                </a:solidFill>
+                <a:latin typeface="Malgun Gothic" pitchFamily="34" charset="0"/>
+                <a:ea typeface="Malgun Gothic" pitchFamily="34" charset="-122"/>
+                <a:cs typeface="Malgun Gothic" pitchFamily="34" charset="-120"/>
+              </a:rPr>
+              <a:t>본 자료에 사용된 주요 기술 용어 정리</a:t>
+            </a:r>
+            <a:endParaRPr lang="en-US" sz="1300" dirty="0"/>
+          </a:p>
+        </p:txBody>
+      </p:sp>
+      <p:sp>
+        <p:nvSpPr>
+          <p:cNvPr id="8" name="Shape 6"/>
+          <p:cNvSpPr/>
+          <p:nvPr/>
+        </p:nvSpPr>
+        <p:spPr>
+          <a:xfrm>
+            <a:off x="457200" y="1417320"/>
+            <a:ext cx="548640" cy="54864"/>
+          </a:xfrm>
+          <a:prstGeom prst="rect">
+            <a:avLst/>
+          </a:prstGeom>
+          <a:solidFill>
+            <a:srgbClr val="4FB3BF"/>
+          </a:solidFill>
+          <a:ln w="12700">
+            <a:solidFill>
+              <a:srgbClr val="4FB3BF"/>
+            </a:solidFill>
+            <a:prstDash val="solid"/>
+          </a:ln>
+        </p:spPr>
+      </p:sp>
+      <p:sp>
+        <p:nvSpPr>
+          <p:cNvPr id="9" name="Shape 7"/>
+          <p:cNvSpPr/>
+          <p:nvPr/>
+        </p:nvSpPr>
+        <p:spPr>
+          <a:xfrm>
+            <a:off x="457200" y="1691640"/>
+            <a:ext cx="5501488" cy="2217420"/>
+          </a:xfrm>
+          <a:prstGeom prst="roundRect">
+            <a:avLst>
+              <a:gd name="adj" fmla="val 4124"/>
+            </a:avLst>
+          </a:prstGeom>
+          <a:solidFill>
+            <a:srgbClr val="FFFFFF"/>
+          </a:solidFill>
+          <a:ln w="9525">
+            <a:solidFill>
+              <a:srgbClr val="CFDCE2"/>
+            </a:solidFill>
+            <a:prstDash val="solid"/>
+          </a:ln>
+        </p:spPr>
+      </p:sp>
+      <p:sp>
+        <p:nvSpPr>
+          <p:cNvPr id="10" name="Shape 8"/>
+          <p:cNvSpPr/>
+          <p:nvPr/>
+        </p:nvSpPr>
+        <p:spPr>
+          <a:xfrm>
+            <a:off x="457200" y="1691640"/>
+            <a:ext cx="109728" cy="2217420"/>
+          </a:xfrm>
+          <a:prstGeom prst="rect">
+            <a:avLst/>
+          </a:prstGeom>
+          <a:solidFill>
+            <a:srgbClr val="0E5C8A"/>
+          </a:solidFill>
+          <a:ln w="12700">
+            <a:solidFill>
+              <a:srgbClr val="0E5C8A"/>
+            </a:solidFill>
+            <a:prstDash val="solid"/>
+          </a:ln>
+        </p:spPr>
+      </p:sp>
+      <p:sp>
+        <p:nvSpPr>
+          <p:cNvPr id="11" name="Text 9"/>
+          <p:cNvSpPr/>
+          <p:nvPr/>
+        </p:nvSpPr>
+        <p:spPr>
+          <a:xfrm>
+            <a:off x="731520" y="1828800"/>
+            <a:ext cx="5135728" cy="292608"/>
+          </a:xfrm>
+          <a:prstGeom prst="rect">
+            <a:avLst/>
+          </a:prstGeom>
+          <a:noFill/>
+          <a:ln/>
+        </p:spPr>
+        <p:txBody>
+          <a:bodyPr wrap="square" rtlCol="0" anchor="ctr"/>
+          <a:lstStyle/>
+          <a:p>
+            <a:pPr indent="0" marL="0">
+              <a:buNone/>
+            </a:pPr>
+            <a:r>
+              <a:rPr lang="en-US" sz="1300" b="1" spc="100" kern="0" dirty="0">
+                <a:solidFill>
+                  <a:srgbClr val="0E5C8A"/>
+                </a:solidFill>
+                <a:latin typeface="Malgun Gothic" pitchFamily="34" charset="0"/>
+                <a:ea typeface="Malgun Gothic" pitchFamily="34" charset="-122"/>
+                <a:cs typeface="Malgun Gothic" pitchFamily="34" charset="-120"/>
+              </a:rPr>
+              <a:t>AI · Model</a:t>
+            </a:r>
+            <a:endParaRPr lang="en-US" sz="1300" dirty="0"/>
+          </a:p>
+        </p:txBody>
+      </p:sp>
+      <p:sp>
+        <p:nvSpPr>
+          <p:cNvPr id="12" name="Text 10"/>
+          <p:cNvSpPr/>
+          <p:nvPr/>
+        </p:nvSpPr>
+        <p:spPr>
+          <a:xfrm>
+            <a:off x="731520" y="2194560"/>
+            <a:ext cx="2377440" cy="297180"/>
+          </a:xfrm>
+          <a:prstGeom prst="rect">
+            <a:avLst/>
+          </a:prstGeom>
+          <a:noFill/>
+          <a:ln/>
+        </p:spPr>
+        <p:txBody>
+          <a:bodyPr wrap="square" rtlCol="0" anchor="t"/>
+          <a:lstStyle/>
+          <a:p>
+            <a:pPr indent="0" marL="0">
+              <a:buNone/>
+            </a:pPr>
+            <a:r>
+              <a:rPr lang="en-US" sz="1000" b="1" dirty="0">
+                <a:solidFill>
+                  <a:srgbClr val="1A2B3C"/>
+                </a:solidFill>
+                <a:latin typeface="Malgun Gothic" pitchFamily="34" charset="0"/>
+                <a:ea typeface="Malgun Gothic" pitchFamily="34" charset="-122"/>
+                <a:cs typeface="Malgun Gothic" pitchFamily="34" charset="-120"/>
+              </a:rPr>
+              <a:t>CNN</a:t>
+            </a:r>
+            <a:endParaRPr lang="en-US" sz="1000" dirty="0"/>
+          </a:p>
+        </p:txBody>
+      </p:sp>
+      <p:sp>
+        <p:nvSpPr>
+          <p:cNvPr id="13" name="Text 11"/>
+          <p:cNvSpPr/>
+          <p:nvPr/>
+        </p:nvSpPr>
+        <p:spPr>
+          <a:xfrm>
+            <a:off x="3154680" y="2194560"/>
+            <a:ext cx="2666848" cy="297180"/>
+          </a:xfrm>
+          <a:prstGeom prst="rect">
+            <a:avLst/>
+          </a:prstGeom>
+          <a:noFill/>
+          <a:ln/>
+        </p:spPr>
+        <p:txBody>
+          <a:bodyPr wrap="square" rtlCol="0" anchor="t"/>
+          <a:lstStyle/>
+          <a:p>
+            <a:pPr indent="0" marL="0">
+              <a:buNone/>
+            </a:pPr>
+            <a:r>
+              <a:rPr lang="en-US" sz="900" dirty="0">
+                <a:solidFill>
+                  <a:srgbClr val="6B7785"/>
+                </a:solidFill>
+                <a:latin typeface="Malgun Gothic" pitchFamily="34" charset="0"/>
+                <a:ea typeface="Malgun Gothic" pitchFamily="34" charset="-122"/>
+                <a:cs typeface="Malgun Gothic" pitchFamily="34" charset="-120"/>
+              </a:rPr>
+              <a:t>Convolutional Neural Network — 이미지 인식의 표준 신경망 구조</a:t>
+            </a:r>
+            <a:endParaRPr lang="en-US" sz="900" dirty="0"/>
+          </a:p>
+        </p:txBody>
+      </p:sp>
+      <p:sp>
+        <p:nvSpPr>
+          <p:cNvPr id="14" name="Text 12"/>
+          <p:cNvSpPr/>
+          <p:nvPr/>
+        </p:nvSpPr>
+        <p:spPr>
+          <a:xfrm>
+            <a:off x="731520" y="2510028"/>
+            <a:ext cx="2377440" cy="297180"/>
+          </a:xfrm>
+          <a:prstGeom prst="rect">
+            <a:avLst/>
+          </a:prstGeom>
+          <a:noFill/>
+          <a:ln/>
+        </p:spPr>
+        <p:txBody>
+          <a:bodyPr wrap="square" rtlCol="0" anchor="t"/>
+          <a:lstStyle/>
+          <a:p>
+            <a:pPr indent="0" marL="0">
+              <a:buNone/>
+            </a:pPr>
+            <a:r>
+              <a:rPr lang="en-US" sz="1000" b="1" dirty="0">
+                <a:solidFill>
+                  <a:srgbClr val="1A2B3C"/>
+                </a:solidFill>
+                <a:latin typeface="Malgun Gothic" pitchFamily="34" charset="0"/>
+                <a:ea typeface="Malgun Gothic" pitchFamily="34" charset="-122"/>
+                <a:cs typeface="Malgun Gothic" pitchFamily="34" charset="-120"/>
+              </a:rPr>
+              <a:t>YOLO</a:t>
+            </a:r>
+            <a:endParaRPr lang="en-US" sz="1000" dirty="0"/>
+          </a:p>
+        </p:txBody>
+      </p:sp>
+      <p:sp>
+        <p:nvSpPr>
+          <p:cNvPr id="15" name="Text 13"/>
+          <p:cNvSpPr/>
+          <p:nvPr/>
+        </p:nvSpPr>
+        <p:spPr>
+          <a:xfrm>
+            <a:off x="3154680" y="2510028"/>
+            <a:ext cx="2666848" cy="297180"/>
+          </a:xfrm>
+          <a:prstGeom prst="rect">
+            <a:avLst/>
+          </a:prstGeom>
+          <a:noFill/>
+          <a:ln/>
+        </p:spPr>
+        <p:txBody>
+          <a:bodyPr wrap="square" rtlCol="0" anchor="t"/>
+          <a:lstStyle/>
+          <a:p>
+            <a:pPr indent="0" marL="0">
+              <a:buNone/>
+            </a:pPr>
+            <a:r>
+              <a:rPr lang="en-US" sz="900" dirty="0">
+                <a:solidFill>
+                  <a:srgbClr val="6B7785"/>
+                </a:solidFill>
+                <a:latin typeface="Malgun Gothic" pitchFamily="34" charset="0"/>
+                <a:ea typeface="Malgun Gothic" pitchFamily="34" charset="-122"/>
+                <a:cs typeface="Malgun Gothic" pitchFamily="34" charset="-120"/>
+              </a:rPr>
+              <a:t>You Only Look Once — 실시간 객체 검출 모델 (위치·크기 한 번에 예측)</a:t>
+            </a:r>
+            <a:endParaRPr lang="en-US" sz="900" dirty="0"/>
+          </a:p>
+        </p:txBody>
+      </p:sp>
+      <p:sp>
+        <p:nvSpPr>
+          <p:cNvPr id="16" name="Text 14"/>
+          <p:cNvSpPr/>
+          <p:nvPr/>
+        </p:nvSpPr>
+        <p:spPr>
+          <a:xfrm>
+            <a:off x="731520" y="2825496"/>
+            <a:ext cx="2377440" cy="297180"/>
+          </a:xfrm>
+          <a:prstGeom prst="rect">
+            <a:avLst/>
+          </a:prstGeom>
+          <a:noFill/>
+          <a:ln/>
+        </p:spPr>
+        <p:txBody>
+          <a:bodyPr wrap="square" rtlCol="0" anchor="t"/>
+          <a:lstStyle/>
+          <a:p>
+            <a:pPr indent="0" marL="0">
+              <a:buNone/>
+            </a:pPr>
+            <a:r>
+              <a:rPr lang="en-US" sz="1000" b="1" dirty="0">
+                <a:solidFill>
+                  <a:srgbClr val="1A2B3C"/>
+                </a:solidFill>
+                <a:latin typeface="Malgun Gothic" pitchFamily="34" charset="0"/>
+                <a:ea typeface="Malgun Gothic" pitchFamily="34" charset="-122"/>
+                <a:cs typeface="Malgun Gothic" pitchFamily="34" charset="-120"/>
+              </a:rPr>
+              <a:t>ResNet / EfficientFormer / MobileViT</a:t>
+            </a:r>
+            <a:endParaRPr lang="en-US" sz="1000" dirty="0"/>
+          </a:p>
+        </p:txBody>
+      </p:sp>
+      <p:sp>
+        <p:nvSpPr>
+          <p:cNvPr id="17" name="Text 15"/>
+          <p:cNvSpPr/>
+          <p:nvPr/>
+        </p:nvSpPr>
+        <p:spPr>
+          <a:xfrm>
+            <a:off x="3154680" y="2825496"/>
+            <a:ext cx="2666848" cy="297180"/>
+          </a:xfrm>
+          <a:prstGeom prst="rect">
+            <a:avLst/>
+          </a:prstGeom>
+          <a:noFill/>
+          <a:ln/>
+        </p:spPr>
+        <p:txBody>
+          <a:bodyPr wrap="square" rtlCol="0" anchor="t"/>
+          <a:lstStyle/>
+          <a:p>
+            <a:pPr indent="0" marL="0">
+              <a:buNone/>
+            </a:pPr>
+            <a:r>
+              <a:rPr lang="en-US" sz="900" dirty="0">
+                <a:solidFill>
+                  <a:srgbClr val="6B7785"/>
+                </a:solidFill>
+                <a:latin typeface="Malgun Gothic" pitchFamily="34" charset="0"/>
+                <a:ea typeface="Malgun Gothic" pitchFamily="34" charset="-122"/>
+                <a:cs typeface="Malgun Gothic" pitchFamily="34" charset="-120"/>
+              </a:rPr>
+              <a:t>이미지 분류용 딥러닝 백본 모델 (점점 가볍고 정확해진 세대별 진화)</a:t>
+            </a:r>
+            <a:endParaRPr lang="en-US" sz="900" dirty="0"/>
+          </a:p>
+        </p:txBody>
+      </p:sp>
+      <p:sp>
+        <p:nvSpPr>
+          <p:cNvPr id="18" name="Text 16"/>
+          <p:cNvSpPr/>
+          <p:nvPr/>
+        </p:nvSpPr>
+        <p:spPr>
+          <a:xfrm>
+            <a:off x="731520" y="3140964"/>
+            <a:ext cx="2377440" cy="297180"/>
+          </a:xfrm>
+          <a:prstGeom prst="rect">
+            <a:avLst/>
+          </a:prstGeom>
+          <a:noFill/>
+          <a:ln/>
+        </p:spPr>
+        <p:txBody>
+          <a:bodyPr wrap="square" rtlCol="0" anchor="t"/>
+          <a:lstStyle/>
+          <a:p>
+            <a:pPr indent="0" marL="0">
+              <a:buNone/>
+            </a:pPr>
+            <a:r>
+              <a:rPr lang="en-US" sz="1000" b="1" dirty="0">
+                <a:solidFill>
+                  <a:srgbClr val="1A2B3C"/>
+                </a:solidFill>
+                <a:latin typeface="Malgun Gothic" pitchFamily="34" charset="0"/>
+                <a:ea typeface="Malgun Gothic" pitchFamily="34" charset="-122"/>
+                <a:cs typeface="Malgun Gothic" pitchFamily="34" charset="-120"/>
+              </a:rPr>
+              <a:t>MobileNet</a:t>
+            </a:r>
+            <a:endParaRPr lang="en-US" sz="1000" dirty="0"/>
+          </a:p>
+        </p:txBody>
+      </p:sp>
+      <p:sp>
+        <p:nvSpPr>
+          <p:cNvPr id="19" name="Text 17"/>
+          <p:cNvSpPr/>
+          <p:nvPr/>
+        </p:nvSpPr>
+        <p:spPr>
+          <a:xfrm>
+            <a:off x="3154680" y="3140964"/>
+            <a:ext cx="2666848" cy="297180"/>
+          </a:xfrm>
+          <a:prstGeom prst="rect">
+            <a:avLst/>
+          </a:prstGeom>
+          <a:noFill/>
+          <a:ln/>
+        </p:spPr>
+        <p:txBody>
+          <a:bodyPr wrap="square" rtlCol="0" anchor="t"/>
+          <a:lstStyle/>
+          <a:p>
+            <a:pPr indent="0" marL="0">
+              <a:buNone/>
+            </a:pPr>
+            <a:r>
+              <a:rPr lang="en-US" sz="900" dirty="0">
+                <a:solidFill>
+                  <a:srgbClr val="6B7785"/>
+                </a:solidFill>
+                <a:latin typeface="Malgun Gothic" pitchFamily="34" charset="0"/>
+                <a:ea typeface="Malgun Gothic" pitchFamily="34" charset="-122"/>
+                <a:cs typeface="Malgun Gothic" pitchFamily="34" charset="-120"/>
+              </a:rPr>
+              <a:t>Google이 만든 모바일용 경량 CNN, 16MB 수준</a:t>
+            </a:r>
+            <a:endParaRPr lang="en-US" sz="900" dirty="0"/>
+          </a:p>
+        </p:txBody>
+      </p:sp>
+      <p:sp>
+        <p:nvSpPr>
+          <p:cNvPr id="20" name="Text 18"/>
+          <p:cNvSpPr/>
+          <p:nvPr/>
+        </p:nvSpPr>
+        <p:spPr>
+          <a:xfrm>
+            <a:off x="731520" y="3456432"/>
+            <a:ext cx="2377440" cy="297180"/>
+          </a:xfrm>
+          <a:prstGeom prst="rect">
+            <a:avLst/>
+          </a:prstGeom>
+          <a:noFill/>
+          <a:ln/>
+        </p:spPr>
+        <p:txBody>
+          <a:bodyPr wrap="square" rtlCol="0" anchor="t"/>
+          <a:lstStyle/>
+          <a:p>
+            <a:pPr indent="0" marL="0">
+              <a:buNone/>
+            </a:pPr>
+            <a:r>
+              <a:rPr lang="en-US" sz="1000" b="1" dirty="0">
+                <a:solidFill>
+                  <a:srgbClr val="1A2B3C"/>
+                </a:solidFill>
+                <a:latin typeface="Malgun Gothic" pitchFamily="34" charset="0"/>
+                <a:ea typeface="Malgun Gothic" pitchFamily="34" charset="-122"/>
+                <a:cs typeface="Malgun Gothic" pitchFamily="34" charset="-120"/>
+              </a:rPr>
+              <a:t>LLM</a:t>
+            </a:r>
+            <a:endParaRPr lang="en-US" sz="1000" dirty="0"/>
+          </a:p>
+        </p:txBody>
+      </p:sp>
+      <p:sp>
+        <p:nvSpPr>
+          <p:cNvPr id="21" name="Text 19"/>
+          <p:cNvSpPr/>
+          <p:nvPr/>
+        </p:nvSpPr>
+        <p:spPr>
+          <a:xfrm>
+            <a:off x="3154680" y="3456432"/>
+            <a:ext cx="2666848" cy="297180"/>
+          </a:xfrm>
+          <a:prstGeom prst="rect">
+            <a:avLst/>
+          </a:prstGeom>
+          <a:noFill/>
+          <a:ln/>
+        </p:spPr>
+        <p:txBody>
+          <a:bodyPr wrap="square" rtlCol="0" anchor="t"/>
+          <a:lstStyle/>
+          <a:p>
+            <a:pPr indent="0" marL="0">
+              <a:buNone/>
+            </a:pPr>
+            <a:r>
+              <a:rPr lang="en-US" sz="900" dirty="0">
+                <a:solidFill>
+                  <a:srgbClr val="6B7785"/>
+                </a:solidFill>
+                <a:latin typeface="Malgun Gothic" pitchFamily="34" charset="0"/>
+                <a:ea typeface="Malgun Gothic" pitchFamily="34" charset="-122"/>
+                <a:cs typeface="Malgun Gothic" pitchFamily="34" charset="-120"/>
+              </a:rPr>
+              <a:t>Large Language Model — GPT-4V, Gemini 등 대형 멀티모달 모델</a:t>
+            </a:r>
+            <a:endParaRPr lang="en-US" sz="900" dirty="0"/>
+          </a:p>
+        </p:txBody>
+      </p:sp>
+      <p:sp>
+        <p:nvSpPr>
+          <p:cNvPr id="22" name="Shape 20"/>
+          <p:cNvSpPr/>
+          <p:nvPr/>
+        </p:nvSpPr>
+        <p:spPr>
+          <a:xfrm>
+            <a:off x="6233008" y="1691640"/>
+            <a:ext cx="5501488" cy="2217420"/>
+          </a:xfrm>
+          <a:prstGeom prst="roundRect">
+            <a:avLst>
+              <a:gd name="adj" fmla="val 4124"/>
+            </a:avLst>
+          </a:prstGeom>
+          <a:solidFill>
+            <a:srgbClr val="FFFFFF"/>
+          </a:solidFill>
+          <a:ln w="9525">
+            <a:solidFill>
+              <a:srgbClr val="CFDCE2"/>
+            </a:solidFill>
+            <a:prstDash val="solid"/>
+          </a:ln>
+        </p:spPr>
+      </p:sp>
+      <p:sp>
+        <p:nvSpPr>
+          <p:cNvPr id="23" name="Shape 21"/>
+          <p:cNvSpPr/>
+          <p:nvPr/>
+        </p:nvSpPr>
+        <p:spPr>
+          <a:xfrm>
+            <a:off x="6233008" y="1691640"/>
+            <a:ext cx="109728" cy="2217420"/>
+          </a:xfrm>
+          <a:prstGeom prst="rect">
+            <a:avLst/>
+          </a:prstGeom>
+          <a:solidFill>
+            <a:srgbClr val="4FB3BF"/>
+          </a:solidFill>
+          <a:ln w="12700">
+            <a:solidFill>
+              <a:srgbClr val="4FB3BF"/>
+            </a:solidFill>
+            <a:prstDash val="solid"/>
+          </a:ln>
+        </p:spPr>
+      </p:sp>
+      <p:sp>
+        <p:nvSpPr>
+          <p:cNvPr id="24" name="Text 22"/>
+          <p:cNvSpPr/>
+          <p:nvPr/>
+        </p:nvSpPr>
+        <p:spPr>
+          <a:xfrm>
+            <a:off x="6507328" y="1828800"/>
+            <a:ext cx="5135728" cy="292608"/>
+          </a:xfrm>
+          <a:prstGeom prst="rect">
+            <a:avLst/>
+          </a:prstGeom>
+          <a:noFill/>
+          <a:ln/>
+        </p:spPr>
+        <p:txBody>
+          <a:bodyPr wrap="square" rtlCol="0" anchor="ctr"/>
+          <a:lstStyle/>
+          <a:p>
+            <a:pPr indent="0" marL="0">
+              <a:buNone/>
+            </a:pPr>
+            <a:r>
+              <a:rPr lang="en-US" sz="1300" b="1" spc="100" kern="0" dirty="0">
+                <a:solidFill>
+                  <a:srgbClr val="4FB3BF"/>
+                </a:solidFill>
+                <a:latin typeface="Malgun Gothic" pitchFamily="34" charset="0"/>
+                <a:ea typeface="Malgun Gothic" pitchFamily="34" charset="-122"/>
+                <a:cs typeface="Malgun Gothic" pitchFamily="34" charset="-120"/>
+              </a:rPr>
+              <a:t>Training · Deployment</a:t>
+            </a:r>
+            <a:endParaRPr lang="en-US" sz="1300" dirty="0"/>
+          </a:p>
+        </p:txBody>
+      </p:sp>
+      <p:sp>
+        <p:nvSpPr>
+          <p:cNvPr id="25" name="Text 23"/>
+          <p:cNvSpPr/>
+          <p:nvPr/>
+        </p:nvSpPr>
+        <p:spPr>
+          <a:xfrm>
+            <a:off x="6507328" y="2194560"/>
+            <a:ext cx="2377440" cy="297180"/>
+          </a:xfrm>
+          <a:prstGeom prst="rect">
+            <a:avLst/>
+          </a:prstGeom>
+          <a:noFill/>
+          <a:ln/>
+        </p:spPr>
+        <p:txBody>
+          <a:bodyPr wrap="square" rtlCol="0" anchor="t"/>
+          <a:lstStyle/>
+          <a:p>
+            <a:pPr indent="0" marL="0">
+              <a:buNone/>
+            </a:pPr>
+            <a:r>
+              <a:rPr lang="en-US" sz="1000" b="1" dirty="0">
+                <a:solidFill>
+                  <a:srgbClr val="1A2B3C"/>
+                </a:solidFill>
+                <a:latin typeface="Malgun Gothic" pitchFamily="34" charset="0"/>
+                <a:ea typeface="Malgun Gothic" pitchFamily="34" charset="-122"/>
+                <a:cs typeface="Malgun Gothic" pitchFamily="34" charset="-120"/>
+              </a:rPr>
+              <a:t>ImageNet</a:t>
+            </a:r>
+            <a:endParaRPr lang="en-US" sz="1000" dirty="0"/>
+          </a:p>
+        </p:txBody>
+      </p:sp>
+      <p:sp>
+        <p:nvSpPr>
+          <p:cNvPr id="26" name="Text 24"/>
+          <p:cNvSpPr/>
+          <p:nvPr/>
+        </p:nvSpPr>
+        <p:spPr>
+          <a:xfrm>
+            <a:off x="8930488" y="2194560"/>
+            <a:ext cx="2666848" cy="297180"/>
+          </a:xfrm>
+          <a:prstGeom prst="rect">
+            <a:avLst/>
+          </a:prstGeom>
+          <a:noFill/>
+          <a:ln/>
+        </p:spPr>
+        <p:txBody>
+          <a:bodyPr wrap="square" rtlCol="0" anchor="t"/>
+          <a:lstStyle/>
+          <a:p>
+            <a:pPr indent="0" marL="0">
+              <a:buNone/>
+            </a:pPr>
+            <a:r>
+              <a:rPr lang="en-US" sz="900" dirty="0">
+                <a:solidFill>
+                  <a:srgbClr val="6B7785"/>
+                </a:solidFill>
+                <a:latin typeface="Malgun Gothic" pitchFamily="34" charset="0"/>
+                <a:ea typeface="Malgun Gothic" pitchFamily="34" charset="-122"/>
+                <a:cs typeface="Malgun Gothic" pitchFamily="34" charset="-120"/>
+              </a:rPr>
+              <a:t>1,400만 장 사진 데이터셋 — 대부분의 비전 모델 사전학습 표준</a:t>
+            </a:r>
+            <a:endParaRPr lang="en-US" sz="900" dirty="0"/>
+          </a:p>
+        </p:txBody>
+      </p:sp>
+      <p:sp>
+        <p:nvSpPr>
+          <p:cNvPr id="27" name="Text 25"/>
+          <p:cNvSpPr/>
+          <p:nvPr/>
+        </p:nvSpPr>
+        <p:spPr>
+          <a:xfrm>
+            <a:off x="6507328" y="2510028"/>
+            <a:ext cx="2377440" cy="297180"/>
+          </a:xfrm>
+          <a:prstGeom prst="rect">
+            <a:avLst/>
+          </a:prstGeom>
+          <a:noFill/>
+          <a:ln/>
+        </p:spPr>
+        <p:txBody>
+          <a:bodyPr wrap="square" rtlCol="0" anchor="t"/>
+          <a:lstStyle/>
+          <a:p>
+            <a:pPr indent="0" marL="0">
+              <a:buNone/>
+            </a:pPr>
+            <a:r>
+              <a:rPr lang="en-US" sz="1000" b="1" dirty="0">
+                <a:solidFill>
+                  <a:srgbClr val="1A2B3C"/>
+                </a:solidFill>
+                <a:latin typeface="Malgun Gothic" pitchFamily="34" charset="0"/>
+                <a:ea typeface="Malgun Gothic" pitchFamily="34" charset="-122"/>
+                <a:cs typeface="Malgun Gothic" pitchFamily="34" charset="-120"/>
+              </a:rPr>
+              <a:t>Fine-tuning</a:t>
+            </a:r>
+            <a:endParaRPr lang="en-US" sz="1000" dirty="0"/>
+          </a:p>
+        </p:txBody>
+      </p:sp>
+      <p:sp>
+        <p:nvSpPr>
+          <p:cNvPr id="28" name="Text 26"/>
+          <p:cNvSpPr/>
+          <p:nvPr/>
+        </p:nvSpPr>
+        <p:spPr>
+          <a:xfrm>
+            <a:off x="8930488" y="2510028"/>
+            <a:ext cx="2666848" cy="297180"/>
+          </a:xfrm>
+          <a:prstGeom prst="rect">
+            <a:avLst/>
+          </a:prstGeom>
+          <a:noFill/>
+          <a:ln/>
+        </p:spPr>
+        <p:txBody>
+          <a:bodyPr wrap="square" rtlCol="0" anchor="t"/>
+          <a:lstStyle/>
+          <a:p>
+            <a:pPr indent="0" marL="0">
+              <a:buNone/>
+            </a:pPr>
+            <a:r>
+              <a:rPr lang="en-US" sz="900" dirty="0">
+                <a:solidFill>
+                  <a:srgbClr val="6B7785"/>
+                </a:solidFill>
+                <a:latin typeface="Malgun Gothic" pitchFamily="34" charset="0"/>
+                <a:ea typeface="Malgun Gothic" pitchFamily="34" charset="-122"/>
+                <a:cs typeface="Malgun Gothic" pitchFamily="34" charset="-120"/>
+              </a:rPr>
+              <a:t>사전학습 모델을 자사 데이터로 추가 학습하여 도메인에 적응시키는 기법</a:t>
+            </a:r>
+            <a:endParaRPr lang="en-US" sz="900" dirty="0"/>
+          </a:p>
+        </p:txBody>
+      </p:sp>
+      <p:sp>
+        <p:nvSpPr>
+          <p:cNvPr id="29" name="Text 27"/>
+          <p:cNvSpPr/>
+          <p:nvPr/>
+        </p:nvSpPr>
+        <p:spPr>
+          <a:xfrm>
+            <a:off x="6507328" y="2825496"/>
+            <a:ext cx="2377440" cy="297180"/>
+          </a:xfrm>
+          <a:prstGeom prst="rect">
+            <a:avLst/>
+          </a:prstGeom>
+          <a:noFill/>
+          <a:ln/>
+        </p:spPr>
+        <p:txBody>
+          <a:bodyPr wrap="square" rtlCol="0" anchor="t"/>
+          <a:lstStyle/>
+          <a:p>
+            <a:pPr indent="0" marL="0">
+              <a:buNone/>
+            </a:pPr>
+            <a:r>
+              <a:rPr lang="en-US" sz="1000" b="1" dirty="0">
+                <a:solidFill>
+                  <a:srgbClr val="1A2B3C"/>
+                </a:solidFill>
+                <a:latin typeface="Malgun Gothic" pitchFamily="34" charset="0"/>
+                <a:ea typeface="Malgun Gothic" pitchFamily="34" charset="-122"/>
+                <a:cs typeface="Malgun Gothic" pitchFamily="34" charset="-120"/>
+              </a:rPr>
+              <a:t>Quantization (int8)</a:t>
+            </a:r>
+            <a:endParaRPr lang="en-US" sz="1000" dirty="0"/>
+          </a:p>
+        </p:txBody>
+      </p:sp>
+      <p:sp>
+        <p:nvSpPr>
+          <p:cNvPr id="30" name="Text 28"/>
+          <p:cNvSpPr/>
+          <p:nvPr/>
+        </p:nvSpPr>
+        <p:spPr>
+          <a:xfrm>
+            <a:off x="8930488" y="2825496"/>
+            <a:ext cx="2666848" cy="297180"/>
+          </a:xfrm>
+          <a:prstGeom prst="rect">
+            <a:avLst/>
+          </a:prstGeom>
+          <a:noFill/>
+          <a:ln/>
+        </p:spPr>
+        <p:txBody>
+          <a:bodyPr wrap="square" rtlCol="0" anchor="t"/>
+          <a:lstStyle/>
+          <a:p>
+            <a:pPr indent="0" marL="0">
+              <a:buNone/>
+            </a:pPr>
+            <a:r>
+              <a:rPr lang="en-US" sz="900" dirty="0">
+                <a:solidFill>
+                  <a:srgbClr val="6B7785"/>
+                </a:solidFill>
+                <a:latin typeface="Malgun Gothic" pitchFamily="34" charset="0"/>
+                <a:ea typeface="Malgun Gothic" pitchFamily="34" charset="-122"/>
+                <a:cs typeface="Malgun Gothic" pitchFamily="34" charset="-120"/>
+              </a:rPr>
+              <a:t>32-bit 모델을 8-bit로 압축 → 모델 크기 1/4, 속도 2~4배 향상</a:t>
+            </a:r>
+            <a:endParaRPr lang="en-US" sz="900" dirty="0"/>
+          </a:p>
+        </p:txBody>
+      </p:sp>
+      <p:sp>
+        <p:nvSpPr>
+          <p:cNvPr id="31" name="Text 29"/>
+          <p:cNvSpPr/>
+          <p:nvPr/>
+        </p:nvSpPr>
+        <p:spPr>
+          <a:xfrm>
+            <a:off x="6507328" y="3140964"/>
+            <a:ext cx="2377440" cy="297180"/>
+          </a:xfrm>
+          <a:prstGeom prst="rect">
+            <a:avLst/>
+          </a:prstGeom>
+          <a:noFill/>
+          <a:ln/>
+        </p:spPr>
+        <p:txBody>
+          <a:bodyPr wrap="square" rtlCol="0" anchor="t"/>
+          <a:lstStyle/>
+          <a:p>
+            <a:pPr indent="0" marL="0">
+              <a:buNone/>
+            </a:pPr>
+            <a:r>
+              <a:rPr lang="en-US" sz="1000" b="1" dirty="0">
+                <a:solidFill>
+                  <a:srgbClr val="1A2B3C"/>
+                </a:solidFill>
+                <a:latin typeface="Malgun Gothic" pitchFamily="34" charset="0"/>
+                <a:ea typeface="Malgun Gothic" pitchFamily="34" charset="-122"/>
+                <a:cs typeface="Malgun Gothic" pitchFamily="34" charset="-120"/>
+              </a:rPr>
+              <a:t>Active Learning</a:t>
+            </a:r>
+            <a:endParaRPr lang="en-US" sz="1000" dirty="0"/>
+          </a:p>
+        </p:txBody>
+      </p:sp>
+      <p:sp>
+        <p:nvSpPr>
+          <p:cNvPr id="32" name="Text 30"/>
+          <p:cNvSpPr/>
+          <p:nvPr/>
+        </p:nvSpPr>
+        <p:spPr>
+          <a:xfrm>
+            <a:off x="8930488" y="3140964"/>
+            <a:ext cx="2666848" cy="297180"/>
+          </a:xfrm>
+          <a:prstGeom prst="rect">
+            <a:avLst/>
+          </a:prstGeom>
+          <a:noFill/>
+          <a:ln/>
+        </p:spPr>
+        <p:txBody>
+          <a:bodyPr wrap="square" rtlCol="0" anchor="t"/>
+          <a:lstStyle/>
+          <a:p>
+            <a:pPr indent="0" marL="0">
+              <a:buNone/>
+            </a:pPr>
+            <a:r>
+              <a:rPr lang="en-US" sz="900" dirty="0">
+                <a:solidFill>
+                  <a:srgbClr val="6B7785"/>
+                </a:solidFill>
+                <a:latin typeface="Malgun Gothic" pitchFamily="34" charset="0"/>
+                <a:ea typeface="Malgun Gothic" pitchFamily="34" charset="-122"/>
+                <a:cs typeface="Malgun Gothic" pitchFamily="34" charset="-120"/>
+              </a:rPr>
+              <a:t>사용자 데이터에서 어려운 샘플만 골라 재학습하는 효율적 학습 사이클</a:t>
+            </a:r>
+            <a:endParaRPr lang="en-US" sz="900" dirty="0"/>
+          </a:p>
+        </p:txBody>
+      </p:sp>
+      <p:sp>
+        <p:nvSpPr>
+          <p:cNvPr id="33" name="Text 31"/>
+          <p:cNvSpPr/>
+          <p:nvPr/>
+        </p:nvSpPr>
+        <p:spPr>
+          <a:xfrm>
+            <a:off x="6507328" y="3456432"/>
+            <a:ext cx="2377440" cy="297180"/>
+          </a:xfrm>
+          <a:prstGeom prst="rect">
+            <a:avLst/>
+          </a:prstGeom>
+          <a:noFill/>
+          <a:ln/>
+        </p:spPr>
+        <p:txBody>
+          <a:bodyPr wrap="square" rtlCol="0" anchor="t"/>
+          <a:lstStyle/>
+          <a:p>
+            <a:pPr indent="0" marL="0">
+              <a:buNone/>
+            </a:pPr>
+            <a:r>
+              <a:rPr lang="en-US" sz="1000" b="1" dirty="0">
+                <a:solidFill>
+                  <a:srgbClr val="1A2B3C"/>
+                </a:solidFill>
+                <a:latin typeface="Malgun Gothic" pitchFamily="34" charset="0"/>
+                <a:ea typeface="Malgun Gothic" pitchFamily="34" charset="-122"/>
+                <a:cs typeface="Malgun Gothic" pitchFamily="34" charset="-120"/>
+              </a:rPr>
+              <a:t>OTA</a:t>
+            </a:r>
+            <a:endParaRPr lang="en-US" sz="1000" dirty="0"/>
+          </a:p>
+        </p:txBody>
+      </p:sp>
+      <p:sp>
+        <p:nvSpPr>
+          <p:cNvPr id="34" name="Text 32"/>
+          <p:cNvSpPr/>
+          <p:nvPr/>
+        </p:nvSpPr>
+        <p:spPr>
+          <a:xfrm>
+            <a:off x="8930488" y="3456432"/>
+            <a:ext cx="2666848" cy="297180"/>
+          </a:xfrm>
+          <a:prstGeom prst="rect">
+            <a:avLst/>
+          </a:prstGeom>
+          <a:noFill/>
+          <a:ln/>
+        </p:spPr>
+        <p:txBody>
+          <a:bodyPr wrap="square" rtlCol="0" anchor="t"/>
+          <a:lstStyle/>
+          <a:p>
+            <a:pPr indent="0" marL="0">
+              <a:buNone/>
+            </a:pPr>
+            <a:r>
+              <a:rPr lang="en-US" sz="900" dirty="0">
+                <a:solidFill>
+                  <a:srgbClr val="6B7785"/>
+                </a:solidFill>
+                <a:latin typeface="Malgun Gothic" pitchFamily="34" charset="0"/>
+                <a:ea typeface="Malgun Gothic" pitchFamily="34" charset="-122"/>
+                <a:cs typeface="Malgun Gothic" pitchFamily="34" charset="-120"/>
+              </a:rPr>
+              <a:t>Over-the-Air — 앱 업데이트 없이 모델 파일만 무선 배포</a:t>
+            </a:r>
+            <a:endParaRPr lang="en-US" sz="900" dirty="0"/>
+          </a:p>
+        </p:txBody>
+      </p:sp>
+      <p:sp>
+        <p:nvSpPr>
+          <p:cNvPr id="35" name="Shape 33"/>
+          <p:cNvSpPr/>
+          <p:nvPr/>
+        </p:nvSpPr>
+        <p:spPr>
+          <a:xfrm>
+            <a:off x="457200" y="4091940"/>
+            <a:ext cx="5501488" cy="2217420"/>
+          </a:xfrm>
+          <a:prstGeom prst="roundRect">
+            <a:avLst>
+              <a:gd name="adj" fmla="val 4124"/>
+            </a:avLst>
+          </a:prstGeom>
+          <a:solidFill>
+            <a:srgbClr val="FFFFFF"/>
+          </a:solidFill>
+          <a:ln w="9525">
+            <a:solidFill>
+              <a:srgbClr val="CFDCE2"/>
+            </a:solidFill>
+            <a:prstDash val="solid"/>
+          </a:ln>
+        </p:spPr>
+      </p:sp>
+      <p:sp>
+        <p:nvSpPr>
+          <p:cNvPr id="36" name="Shape 34"/>
+          <p:cNvSpPr/>
+          <p:nvPr/>
+        </p:nvSpPr>
+        <p:spPr>
+          <a:xfrm>
+            <a:off x="457200" y="4091940"/>
+            <a:ext cx="109728" cy="2217420"/>
+          </a:xfrm>
+          <a:prstGeom prst="rect">
+            <a:avLst/>
+          </a:prstGeom>
+          <a:solidFill>
+            <a:srgbClr val="2E7D5B"/>
+          </a:solidFill>
+          <a:ln w="12700">
+            <a:solidFill>
+              <a:srgbClr val="2E7D5B"/>
+            </a:solidFill>
+            <a:prstDash val="solid"/>
+          </a:ln>
+        </p:spPr>
+      </p:sp>
+      <p:sp>
+        <p:nvSpPr>
+          <p:cNvPr id="37" name="Text 35"/>
+          <p:cNvSpPr/>
+          <p:nvPr/>
+        </p:nvSpPr>
+        <p:spPr>
+          <a:xfrm>
+            <a:off x="731520" y="4229100"/>
+            <a:ext cx="5135728" cy="292608"/>
+          </a:xfrm>
+          <a:prstGeom prst="rect">
+            <a:avLst/>
+          </a:prstGeom>
+          <a:noFill/>
+          <a:ln/>
+        </p:spPr>
+        <p:txBody>
+          <a:bodyPr wrap="square" rtlCol="0" anchor="ctr"/>
+          <a:lstStyle/>
+          <a:p>
+            <a:pPr indent="0" marL="0">
+              <a:buNone/>
+            </a:pPr>
+            <a:r>
+              <a:rPr lang="en-US" sz="1300" b="1" spc="100" kern="0" dirty="0">
+                <a:solidFill>
+                  <a:srgbClr val="2E7D5B"/>
+                </a:solidFill>
+                <a:latin typeface="Malgun Gothic" pitchFamily="34" charset="0"/>
+                <a:ea typeface="Malgun Gothic" pitchFamily="34" charset="-122"/>
+                <a:cs typeface="Malgun Gothic" pitchFamily="34" charset="-120"/>
+              </a:rPr>
+              <a:t>Vision · Camera</a:t>
+            </a:r>
+            <a:endParaRPr lang="en-US" sz="1300" dirty="0"/>
+          </a:p>
+        </p:txBody>
+      </p:sp>
+      <p:sp>
+        <p:nvSpPr>
+          <p:cNvPr id="38" name="Text 36"/>
+          <p:cNvSpPr/>
+          <p:nvPr/>
+        </p:nvSpPr>
+        <p:spPr>
+          <a:xfrm>
+            <a:off x="731520" y="4594860"/>
+            <a:ext cx="2377440" cy="297180"/>
+          </a:xfrm>
+          <a:prstGeom prst="rect">
+            <a:avLst/>
+          </a:prstGeom>
+          <a:noFill/>
+          <a:ln/>
+        </p:spPr>
+        <p:txBody>
+          <a:bodyPr wrap="square" rtlCol="0" anchor="t"/>
+          <a:lstStyle/>
+          <a:p>
+            <a:pPr indent="0" marL="0">
+              <a:buNone/>
+            </a:pPr>
+            <a:r>
+              <a:rPr lang="en-US" sz="1000" b="1" dirty="0">
+                <a:solidFill>
+                  <a:srgbClr val="1A2B3C"/>
+                </a:solidFill>
+                <a:latin typeface="Malgun Gothic" pitchFamily="34" charset="0"/>
+                <a:ea typeface="Malgun Gothic" pitchFamily="34" charset="-122"/>
+                <a:cs typeface="Malgun Gothic" pitchFamily="34" charset="-120"/>
+              </a:rPr>
+              <a:t>TTI</a:t>
+            </a:r>
+            <a:endParaRPr lang="en-US" sz="1000" dirty="0"/>
+          </a:p>
+        </p:txBody>
+      </p:sp>
+      <p:sp>
+        <p:nvSpPr>
+          <p:cNvPr id="39" name="Text 37"/>
+          <p:cNvSpPr/>
+          <p:nvPr/>
+        </p:nvSpPr>
+        <p:spPr>
+          <a:xfrm>
+            <a:off x="3154680" y="4594860"/>
+            <a:ext cx="2666848" cy="297180"/>
+          </a:xfrm>
+          <a:prstGeom prst="rect">
+            <a:avLst/>
+          </a:prstGeom>
+          <a:noFill/>
+          <a:ln/>
+        </p:spPr>
+        <p:txBody>
+          <a:bodyPr wrap="square" rtlCol="0" anchor="t"/>
+          <a:lstStyle/>
+          <a:p>
+            <a:pPr indent="0" marL="0">
+              <a:buNone/>
+            </a:pPr>
+            <a:r>
+              <a:rPr lang="en-US" sz="900" dirty="0">
+                <a:solidFill>
+                  <a:srgbClr val="6B7785"/>
+                </a:solidFill>
+                <a:latin typeface="Malgun Gothic" pitchFamily="34" charset="0"/>
+                <a:ea typeface="Malgun Gothic" pitchFamily="34" charset="-122"/>
+                <a:cs typeface="Malgun Gothic" pitchFamily="34" charset="-120"/>
+              </a:rPr>
+              <a:t>Time-Temperature Indicator — 온도·시간에 따라 색이 변하는 식품 신선도 칩</a:t>
+            </a:r>
+            <a:endParaRPr lang="en-US" sz="900" dirty="0"/>
+          </a:p>
+        </p:txBody>
+      </p:sp>
+      <p:sp>
+        <p:nvSpPr>
+          <p:cNvPr id="40" name="Text 38"/>
+          <p:cNvSpPr/>
+          <p:nvPr/>
+        </p:nvSpPr>
+        <p:spPr>
+          <a:xfrm>
+            <a:off x="731520" y="4910328"/>
+            <a:ext cx="2377440" cy="297180"/>
+          </a:xfrm>
+          <a:prstGeom prst="rect">
+            <a:avLst/>
+          </a:prstGeom>
+          <a:noFill/>
+          <a:ln/>
+        </p:spPr>
+        <p:txBody>
+          <a:bodyPr wrap="square" rtlCol="0" anchor="t"/>
+          <a:lstStyle/>
+          <a:p>
+            <a:pPr indent="0" marL="0">
+              <a:buNone/>
+            </a:pPr>
+            <a:r>
+              <a:rPr lang="en-US" sz="1000" b="1" dirty="0">
+                <a:solidFill>
+                  <a:srgbClr val="1A2B3C"/>
+                </a:solidFill>
+                <a:latin typeface="Malgun Gothic" pitchFamily="34" charset="0"/>
+                <a:ea typeface="Malgun Gothic" pitchFamily="34" charset="-122"/>
+                <a:cs typeface="Malgun Gothic" pitchFamily="34" charset="-120"/>
+              </a:rPr>
+              <a:t>ROI</a:t>
+            </a:r>
+            <a:endParaRPr lang="en-US" sz="1000" dirty="0"/>
+          </a:p>
+        </p:txBody>
+      </p:sp>
+      <p:sp>
+        <p:nvSpPr>
+          <p:cNvPr id="41" name="Text 39"/>
+          <p:cNvSpPr/>
+          <p:nvPr/>
+        </p:nvSpPr>
+        <p:spPr>
+          <a:xfrm>
+            <a:off x="3154680" y="4910328"/>
+            <a:ext cx="2666848" cy="297180"/>
+          </a:xfrm>
+          <a:prstGeom prst="rect">
+            <a:avLst/>
+          </a:prstGeom>
+          <a:noFill/>
+          <a:ln/>
+        </p:spPr>
+        <p:txBody>
+          <a:bodyPr wrap="square" rtlCol="0" anchor="t"/>
+          <a:lstStyle/>
+          <a:p>
+            <a:pPr indent="0" marL="0">
+              <a:buNone/>
+            </a:pPr>
+            <a:r>
+              <a:rPr lang="en-US" sz="900" dirty="0">
+                <a:solidFill>
+                  <a:srgbClr val="6B7785"/>
+                </a:solidFill>
+                <a:latin typeface="Malgun Gothic" pitchFamily="34" charset="0"/>
+                <a:ea typeface="Malgun Gothic" pitchFamily="34" charset="-122"/>
+                <a:cs typeface="Malgun Gothic" pitchFamily="34" charset="-120"/>
+              </a:rPr>
+              <a:t>Region of Interest — 분석 대상 영역 (앱의 점선 원 안쪽)</a:t>
+            </a:r>
+            <a:endParaRPr lang="en-US" sz="900" dirty="0"/>
+          </a:p>
+        </p:txBody>
+      </p:sp>
+      <p:sp>
+        <p:nvSpPr>
+          <p:cNvPr id="42" name="Text 40"/>
+          <p:cNvSpPr/>
+          <p:nvPr/>
+        </p:nvSpPr>
+        <p:spPr>
+          <a:xfrm>
+            <a:off x="731520" y="5225796"/>
+            <a:ext cx="2377440" cy="297180"/>
+          </a:xfrm>
+          <a:prstGeom prst="rect">
+            <a:avLst/>
+          </a:prstGeom>
+          <a:noFill/>
+          <a:ln/>
+        </p:spPr>
+        <p:txBody>
+          <a:bodyPr wrap="square" rtlCol="0" anchor="t"/>
+          <a:lstStyle/>
+          <a:p>
+            <a:pPr indent="0" marL="0">
+              <a:buNone/>
+            </a:pPr>
+            <a:r>
+              <a:rPr lang="en-US" sz="1000" b="1" dirty="0">
+                <a:solidFill>
+                  <a:srgbClr val="1A2B3C"/>
+                </a:solidFill>
+                <a:latin typeface="Malgun Gothic" pitchFamily="34" charset="0"/>
+                <a:ea typeface="Malgun Gothic" pitchFamily="34" charset="-122"/>
+                <a:cs typeface="Malgun Gothic" pitchFamily="34" charset="-120"/>
+              </a:rPr>
+              <a:t>WB</a:t>
+            </a:r>
+            <a:endParaRPr lang="en-US" sz="1000" dirty="0"/>
+          </a:p>
+        </p:txBody>
+      </p:sp>
+      <p:sp>
+        <p:nvSpPr>
+          <p:cNvPr id="43" name="Text 41"/>
+          <p:cNvSpPr/>
+          <p:nvPr/>
+        </p:nvSpPr>
+        <p:spPr>
+          <a:xfrm>
+            <a:off x="3154680" y="5225796"/>
+            <a:ext cx="2666848" cy="297180"/>
+          </a:xfrm>
+          <a:prstGeom prst="rect">
+            <a:avLst/>
+          </a:prstGeom>
+          <a:noFill/>
+          <a:ln/>
+        </p:spPr>
+        <p:txBody>
+          <a:bodyPr wrap="square" rtlCol="0" anchor="t"/>
+          <a:lstStyle/>
+          <a:p>
+            <a:pPr indent="0" marL="0">
+              <a:buNone/>
+            </a:pPr>
+            <a:r>
+              <a:rPr lang="en-US" sz="900" dirty="0">
+                <a:solidFill>
+                  <a:srgbClr val="6B7785"/>
+                </a:solidFill>
+                <a:latin typeface="Malgun Gothic" pitchFamily="34" charset="0"/>
+                <a:ea typeface="Malgun Gothic" pitchFamily="34" charset="-122"/>
+                <a:cs typeface="Malgun Gothic" pitchFamily="34" charset="-120"/>
+              </a:rPr>
+              <a:t>White Balance — 광원에 따라 달라지는 색감을 보정</a:t>
+            </a:r>
+            <a:endParaRPr lang="en-US" sz="900" dirty="0"/>
+          </a:p>
+        </p:txBody>
+      </p:sp>
+      <p:sp>
+        <p:nvSpPr>
+          <p:cNvPr id="44" name="Text 42"/>
+          <p:cNvSpPr/>
+          <p:nvPr/>
+        </p:nvSpPr>
+        <p:spPr>
+          <a:xfrm>
+            <a:off x="731520" y="5541264"/>
+            <a:ext cx="2377440" cy="297180"/>
+          </a:xfrm>
+          <a:prstGeom prst="rect">
+            <a:avLst/>
+          </a:prstGeom>
+          <a:noFill/>
+          <a:ln/>
+        </p:spPr>
+        <p:txBody>
+          <a:bodyPr wrap="square" rtlCol="0" anchor="t"/>
+          <a:lstStyle/>
+          <a:p>
+            <a:pPr indent="0" marL="0">
+              <a:buNone/>
+            </a:pPr>
+            <a:r>
+              <a:rPr lang="en-US" sz="1000" b="1" dirty="0">
+                <a:solidFill>
+                  <a:srgbClr val="1A2B3C"/>
+                </a:solidFill>
+                <a:latin typeface="Malgun Gothic" pitchFamily="34" charset="0"/>
+                <a:ea typeface="Malgun Gothic" pitchFamily="34" charset="-122"/>
+                <a:cs typeface="Malgun Gothic" pitchFamily="34" charset="-120"/>
+              </a:rPr>
+              <a:t>Perspective Correction</a:t>
+            </a:r>
+            <a:endParaRPr lang="en-US" sz="1000" dirty="0"/>
+          </a:p>
+        </p:txBody>
+      </p:sp>
+      <p:sp>
+        <p:nvSpPr>
+          <p:cNvPr id="45" name="Text 43"/>
+          <p:cNvSpPr/>
+          <p:nvPr/>
+        </p:nvSpPr>
+        <p:spPr>
+          <a:xfrm>
+            <a:off x="3154680" y="5541264"/>
+            <a:ext cx="2666848" cy="297180"/>
+          </a:xfrm>
+          <a:prstGeom prst="rect">
+            <a:avLst/>
+          </a:prstGeom>
+          <a:noFill/>
+          <a:ln/>
+        </p:spPr>
+        <p:txBody>
+          <a:bodyPr wrap="square" rtlCol="0" anchor="t"/>
+          <a:lstStyle/>
+          <a:p>
+            <a:pPr indent="0" marL="0">
+              <a:buNone/>
+            </a:pPr>
+            <a:r>
+              <a:rPr lang="en-US" sz="900" dirty="0">
+                <a:solidFill>
+                  <a:srgbClr val="6B7785"/>
+                </a:solidFill>
+                <a:latin typeface="Malgun Gothic" pitchFamily="34" charset="0"/>
+                <a:ea typeface="Malgun Gothic" pitchFamily="34" charset="-122"/>
+                <a:cs typeface="Malgun Gothic" pitchFamily="34" charset="-120"/>
+              </a:rPr>
+              <a:t>비스듬히 찍힌 칩을 정원으로 펴는 원근 보정</a:t>
+            </a:r>
+            <a:endParaRPr lang="en-US" sz="900" dirty="0"/>
+          </a:p>
+        </p:txBody>
+      </p:sp>
+      <p:sp>
+        <p:nvSpPr>
+          <p:cNvPr id="46" name="Text 44"/>
+          <p:cNvSpPr/>
+          <p:nvPr/>
+        </p:nvSpPr>
+        <p:spPr>
+          <a:xfrm>
+            <a:off x="731520" y="5856732"/>
+            <a:ext cx="2377440" cy="297180"/>
+          </a:xfrm>
+          <a:prstGeom prst="rect">
+            <a:avLst/>
+          </a:prstGeom>
+          <a:noFill/>
+          <a:ln/>
+        </p:spPr>
+        <p:txBody>
+          <a:bodyPr wrap="square" rtlCol="0" anchor="t"/>
+          <a:lstStyle/>
+          <a:p>
+            <a:pPr indent="0" marL="0">
+              <a:buNone/>
+            </a:pPr>
+            <a:r>
+              <a:rPr lang="en-US" sz="1000" b="1" dirty="0">
+                <a:solidFill>
+                  <a:srgbClr val="1A2B3C"/>
+                </a:solidFill>
+                <a:latin typeface="Malgun Gothic" pitchFamily="34" charset="0"/>
+                <a:ea typeface="Malgun Gothic" pitchFamily="34" charset="-122"/>
+                <a:cs typeface="Malgun Gothic" pitchFamily="34" charset="-120"/>
+              </a:rPr>
+              <a:t>OpenCV</a:t>
+            </a:r>
+            <a:endParaRPr lang="en-US" sz="1000" dirty="0"/>
+          </a:p>
+        </p:txBody>
+      </p:sp>
+      <p:sp>
+        <p:nvSpPr>
+          <p:cNvPr id="47" name="Text 45"/>
+          <p:cNvSpPr/>
+          <p:nvPr/>
+        </p:nvSpPr>
+        <p:spPr>
+          <a:xfrm>
+            <a:off x="3154680" y="5856732"/>
+            <a:ext cx="2666848" cy="297180"/>
+          </a:xfrm>
+          <a:prstGeom prst="rect">
+            <a:avLst/>
+          </a:prstGeom>
+          <a:noFill/>
+          <a:ln/>
+        </p:spPr>
+        <p:txBody>
+          <a:bodyPr wrap="square" rtlCol="0" anchor="t"/>
+          <a:lstStyle/>
+          <a:p>
+            <a:pPr indent="0" marL="0">
+              <a:buNone/>
+            </a:pPr>
+            <a:r>
+              <a:rPr lang="en-US" sz="900" dirty="0">
+                <a:solidFill>
+                  <a:srgbClr val="6B7785"/>
+                </a:solidFill>
+                <a:latin typeface="Malgun Gothic" pitchFamily="34" charset="0"/>
+                <a:ea typeface="Malgun Gothic" pitchFamily="34" charset="-122"/>
+                <a:cs typeface="Malgun Gothic" pitchFamily="34" charset="-120"/>
+              </a:rPr>
+              <a:t>오픈소스 컴퓨터비전 라이브러리 — 모바일 영상 전처리 표준</a:t>
+            </a:r>
+            <a:endParaRPr lang="en-US" sz="900" dirty="0"/>
+          </a:p>
+        </p:txBody>
+      </p:sp>
+      <p:sp>
+        <p:nvSpPr>
+          <p:cNvPr id="48" name="Shape 46"/>
+          <p:cNvSpPr/>
+          <p:nvPr/>
+        </p:nvSpPr>
+        <p:spPr>
+          <a:xfrm>
+            <a:off x="6233008" y="4091940"/>
+            <a:ext cx="5501488" cy="2217420"/>
+          </a:xfrm>
+          <a:prstGeom prst="roundRect">
+            <a:avLst>
+              <a:gd name="adj" fmla="val 4124"/>
+            </a:avLst>
+          </a:prstGeom>
+          <a:solidFill>
+            <a:srgbClr val="FFFFFF"/>
+          </a:solidFill>
+          <a:ln w="9525">
+            <a:solidFill>
+              <a:srgbClr val="CFDCE2"/>
+            </a:solidFill>
+            <a:prstDash val="solid"/>
+          </a:ln>
+        </p:spPr>
+      </p:sp>
+      <p:sp>
+        <p:nvSpPr>
+          <p:cNvPr id="49" name="Shape 47"/>
+          <p:cNvSpPr/>
+          <p:nvPr/>
+        </p:nvSpPr>
+        <p:spPr>
+          <a:xfrm>
+            <a:off x="6233008" y="4091940"/>
+            <a:ext cx="109728" cy="2217420"/>
+          </a:xfrm>
+          <a:prstGeom prst="rect">
+            <a:avLst/>
+          </a:prstGeom>
+          <a:solidFill>
+            <a:srgbClr val="C77E1E"/>
+          </a:solidFill>
+          <a:ln w="12700">
+            <a:solidFill>
+              <a:srgbClr val="C77E1E"/>
+            </a:solidFill>
+            <a:prstDash val="solid"/>
+          </a:ln>
+        </p:spPr>
+      </p:sp>
+      <p:sp>
+        <p:nvSpPr>
+          <p:cNvPr id="50" name="Text 48"/>
+          <p:cNvSpPr/>
+          <p:nvPr/>
+        </p:nvSpPr>
+        <p:spPr>
+          <a:xfrm>
+            <a:off x="6507328" y="4229100"/>
+            <a:ext cx="5135728" cy="292608"/>
+          </a:xfrm>
+          <a:prstGeom prst="rect">
+            <a:avLst/>
+          </a:prstGeom>
+          <a:noFill/>
+          <a:ln/>
+        </p:spPr>
+        <p:txBody>
+          <a:bodyPr wrap="square" rtlCol="0" anchor="ctr"/>
+          <a:lstStyle/>
+          <a:p>
+            <a:pPr indent="0" marL="0">
+              <a:buNone/>
+            </a:pPr>
+            <a:r>
+              <a:rPr lang="en-US" sz="1300" b="1" spc="100" kern="0" dirty="0">
+                <a:solidFill>
+                  <a:srgbClr val="C77E1E"/>
+                </a:solidFill>
+                <a:latin typeface="Malgun Gothic" pitchFamily="34" charset="0"/>
+                <a:ea typeface="Malgun Gothic" pitchFamily="34" charset="-122"/>
+                <a:cs typeface="Malgun Gothic" pitchFamily="34" charset="-120"/>
+              </a:rPr>
+              <a:t>Platform · App</a:t>
+            </a:r>
+            <a:endParaRPr lang="en-US" sz="1300" dirty="0"/>
+          </a:p>
+        </p:txBody>
+      </p:sp>
+      <p:sp>
+        <p:nvSpPr>
+          <p:cNvPr id="51" name="Text 49"/>
+          <p:cNvSpPr/>
+          <p:nvPr/>
+        </p:nvSpPr>
+        <p:spPr>
+          <a:xfrm>
+            <a:off x="6507328" y="4594860"/>
+            <a:ext cx="2377440" cy="297180"/>
+          </a:xfrm>
+          <a:prstGeom prst="rect">
+            <a:avLst/>
+          </a:prstGeom>
+          <a:noFill/>
+          <a:ln/>
+        </p:spPr>
+        <p:txBody>
+          <a:bodyPr wrap="square" rtlCol="0" anchor="t"/>
+          <a:lstStyle/>
+          <a:p>
+            <a:pPr indent="0" marL="0">
+              <a:buNone/>
+            </a:pPr>
+            <a:r>
+              <a:rPr lang="en-US" sz="1000" b="1" dirty="0">
+                <a:solidFill>
+                  <a:srgbClr val="1A2B3C"/>
+                </a:solidFill>
+                <a:latin typeface="Malgun Gothic" pitchFamily="34" charset="0"/>
+                <a:ea typeface="Malgun Gothic" pitchFamily="34" charset="-122"/>
+                <a:cs typeface="Malgun Gothic" pitchFamily="34" charset="-120"/>
+              </a:rPr>
+              <a:t>PoC</a:t>
+            </a:r>
+            <a:endParaRPr lang="en-US" sz="1000" dirty="0"/>
+          </a:p>
+        </p:txBody>
+      </p:sp>
+      <p:sp>
+        <p:nvSpPr>
+          <p:cNvPr id="52" name="Text 50"/>
+          <p:cNvSpPr/>
+          <p:nvPr/>
+        </p:nvSpPr>
+        <p:spPr>
+          <a:xfrm>
+            <a:off x="8930488" y="4594860"/>
+            <a:ext cx="2666848" cy="297180"/>
+          </a:xfrm>
+          <a:prstGeom prst="rect">
+            <a:avLst/>
+          </a:prstGeom>
+          <a:noFill/>
+          <a:ln/>
+        </p:spPr>
+        <p:txBody>
+          <a:bodyPr wrap="square" rtlCol="0" anchor="t"/>
+          <a:lstStyle/>
+          <a:p>
+            <a:pPr indent="0" marL="0">
+              <a:buNone/>
+            </a:pPr>
+            <a:r>
+              <a:rPr lang="en-US" sz="900" dirty="0">
+                <a:solidFill>
+                  <a:srgbClr val="6B7785"/>
+                </a:solidFill>
+                <a:latin typeface="Malgun Gothic" pitchFamily="34" charset="0"/>
+                <a:ea typeface="Malgun Gothic" pitchFamily="34" charset="-122"/>
+                <a:cs typeface="Malgun Gothic" pitchFamily="34" charset="-120"/>
+              </a:rPr>
+              <a:t>Proof of Concept — 기술 개념 검증용 시제품 (현재 데모)</a:t>
+            </a:r>
+            <a:endParaRPr lang="en-US" sz="900" dirty="0"/>
+          </a:p>
+        </p:txBody>
+      </p:sp>
+      <p:sp>
+        <p:nvSpPr>
+          <p:cNvPr id="53" name="Text 51"/>
+          <p:cNvSpPr/>
+          <p:nvPr/>
+        </p:nvSpPr>
+        <p:spPr>
+          <a:xfrm>
+            <a:off x="6507328" y="4910328"/>
+            <a:ext cx="2377440" cy="297180"/>
+          </a:xfrm>
+          <a:prstGeom prst="rect">
+            <a:avLst/>
+          </a:prstGeom>
+          <a:noFill/>
+          <a:ln/>
+        </p:spPr>
+        <p:txBody>
+          <a:bodyPr wrap="square" rtlCol="0" anchor="t"/>
+          <a:lstStyle/>
+          <a:p>
+            <a:pPr indent="0" marL="0">
+              <a:buNone/>
+            </a:pPr>
+            <a:r>
+              <a:rPr lang="en-US" sz="1000" b="1" dirty="0">
+                <a:solidFill>
+                  <a:srgbClr val="1A2B3C"/>
+                </a:solidFill>
+                <a:latin typeface="Malgun Gothic" pitchFamily="34" charset="0"/>
+                <a:ea typeface="Malgun Gothic" pitchFamily="34" charset="-122"/>
+                <a:cs typeface="Malgun Gothic" pitchFamily="34" charset="-120"/>
+              </a:rPr>
+              <a:t>PWA</a:t>
+            </a:r>
+            <a:endParaRPr lang="en-US" sz="1000" dirty="0"/>
+          </a:p>
+        </p:txBody>
+      </p:sp>
+      <p:sp>
+        <p:nvSpPr>
+          <p:cNvPr id="54" name="Text 52"/>
+          <p:cNvSpPr/>
+          <p:nvPr/>
+        </p:nvSpPr>
+        <p:spPr>
+          <a:xfrm>
+            <a:off x="8930488" y="4910328"/>
+            <a:ext cx="2666848" cy="297180"/>
+          </a:xfrm>
+          <a:prstGeom prst="rect">
+            <a:avLst/>
+          </a:prstGeom>
+          <a:noFill/>
+          <a:ln/>
+        </p:spPr>
+        <p:txBody>
+          <a:bodyPr wrap="square" rtlCol="0" anchor="t"/>
+          <a:lstStyle/>
+          <a:p>
+            <a:pPr indent="0" marL="0">
+              <a:buNone/>
+            </a:pPr>
+            <a:r>
+              <a:rPr lang="en-US" sz="900" dirty="0">
+                <a:solidFill>
+                  <a:srgbClr val="6B7785"/>
+                </a:solidFill>
+                <a:latin typeface="Malgun Gothic" pitchFamily="34" charset="0"/>
+                <a:ea typeface="Malgun Gothic" pitchFamily="34" charset="-122"/>
+                <a:cs typeface="Malgun Gothic" pitchFamily="34" charset="-120"/>
+              </a:rPr>
+              <a:t>Progressive Web App — 설치 가능한 웹 기반 앱</a:t>
+            </a:r>
+            <a:endParaRPr lang="en-US" sz="900" dirty="0"/>
+          </a:p>
+        </p:txBody>
+      </p:sp>
+      <p:sp>
+        <p:nvSpPr>
+          <p:cNvPr id="55" name="Text 53"/>
+          <p:cNvSpPr/>
+          <p:nvPr/>
+        </p:nvSpPr>
+        <p:spPr>
+          <a:xfrm>
+            <a:off x="6507328" y="5225796"/>
+            <a:ext cx="2377440" cy="297180"/>
+          </a:xfrm>
+          <a:prstGeom prst="rect">
+            <a:avLst/>
+          </a:prstGeom>
+          <a:noFill/>
+          <a:ln/>
+        </p:spPr>
+        <p:txBody>
+          <a:bodyPr wrap="square" rtlCol="0" anchor="t"/>
+          <a:lstStyle/>
+          <a:p>
+            <a:pPr indent="0" marL="0">
+              <a:buNone/>
+            </a:pPr>
+            <a:r>
+              <a:rPr lang="en-US" sz="1000" b="1" dirty="0">
+                <a:solidFill>
+                  <a:srgbClr val="1A2B3C"/>
+                </a:solidFill>
+                <a:latin typeface="Malgun Gothic" pitchFamily="34" charset="0"/>
+                <a:ea typeface="Malgun Gothic" pitchFamily="34" charset="-122"/>
+                <a:cs typeface="Malgun Gothic" pitchFamily="34" charset="-120"/>
+              </a:rPr>
+              <a:t>TFJS / TFLite / Core ML</a:t>
+            </a:r>
+            <a:endParaRPr lang="en-US" sz="1000" dirty="0"/>
+          </a:p>
+        </p:txBody>
+      </p:sp>
+      <p:sp>
+        <p:nvSpPr>
+          <p:cNvPr id="56" name="Text 54"/>
+          <p:cNvSpPr/>
+          <p:nvPr/>
+        </p:nvSpPr>
+        <p:spPr>
+          <a:xfrm>
+            <a:off x="8930488" y="5225796"/>
+            <a:ext cx="2666848" cy="297180"/>
+          </a:xfrm>
+          <a:prstGeom prst="rect">
+            <a:avLst/>
+          </a:prstGeom>
+          <a:noFill/>
+          <a:ln/>
+        </p:spPr>
+        <p:txBody>
+          <a:bodyPr wrap="square" rtlCol="0" anchor="t"/>
+          <a:lstStyle/>
+          <a:p>
+            <a:pPr indent="0" marL="0">
+              <a:buNone/>
+            </a:pPr>
+            <a:r>
+              <a:rPr lang="en-US" sz="900" dirty="0">
+                <a:solidFill>
+                  <a:srgbClr val="6B7785"/>
+                </a:solidFill>
+                <a:latin typeface="Malgun Gothic" pitchFamily="34" charset="0"/>
+                <a:ea typeface="Malgun Gothic" pitchFamily="34" charset="-122"/>
+                <a:cs typeface="Malgun Gothic" pitchFamily="34" charset="-120"/>
+              </a:rPr>
+              <a:t>TensorFlow.js (브라우저) / TensorFlow Lite (Android) / Core ML (iOS) 추론 엔진</a:t>
+            </a:r>
+            <a:endParaRPr lang="en-US" sz="900" dirty="0"/>
+          </a:p>
+        </p:txBody>
+      </p:sp>
+      <p:sp>
+        <p:nvSpPr>
+          <p:cNvPr id="57" name="Text 55"/>
+          <p:cNvSpPr/>
+          <p:nvPr/>
+        </p:nvSpPr>
+        <p:spPr>
+          <a:xfrm>
+            <a:off x="6507328" y="5541264"/>
+            <a:ext cx="2377440" cy="297180"/>
+          </a:xfrm>
+          <a:prstGeom prst="rect">
+            <a:avLst/>
+          </a:prstGeom>
+          <a:noFill/>
+          <a:ln/>
+        </p:spPr>
+        <p:txBody>
+          <a:bodyPr wrap="square" rtlCol="0" anchor="t"/>
+          <a:lstStyle/>
+          <a:p>
+            <a:pPr indent="0" marL="0">
+              <a:buNone/>
+            </a:pPr>
+            <a:r>
+              <a:rPr lang="en-US" sz="1000" b="1" dirty="0">
+                <a:solidFill>
+                  <a:srgbClr val="1A2B3C"/>
+                </a:solidFill>
+                <a:latin typeface="Malgun Gothic" pitchFamily="34" charset="0"/>
+                <a:ea typeface="Malgun Gothic" pitchFamily="34" charset="-122"/>
+                <a:cs typeface="Malgun Gothic" pitchFamily="34" charset="-120"/>
+              </a:rPr>
+              <a:t>Camera2 / AVFoundation</a:t>
+            </a:r>
+            <a:endParaRPr lang="en-US" sz="1000" dirty="0"/>
+          </a:p>
+        </p:txBody>
+      </p:sp>
+      <p:sp>
+        <p:nvSpPr>
+          <p:cNvPr id="58" name="Text 56"/>
+          <p:cNvSpPr/>
+          <p:nvPr/>
+        </p:nvSpPr>
+        <p:spPr>
+          <a:xfrm>
+            <a:off x="8930488" y="5541264"/>
+            <a:ext cx="2666848" cy="297180"/>
+          </a:xfrm>
+          <a:prstGeom prst="rect">
+            <a:avLst/>
+          </a:prstGeom>
+          <a:noFill/>
+          <a:ln/>
+        </p:spPr>
+        <p:txBody>
+          <a:bodyPr wrap="square" rtlCol="0" anchor="t"/>
+          <a:lstStyle/>
+          <a:p>
+            <a:pPr indent="0" marL="0">
+              <a:buNone/>
+            </a:pPr>
+            <a:r>
+              <a:rPr lang="en-US" sz="900" dirty="0">
+                <a:solidFill>
+                  <a:srgbClr val="6B7785"/>
+                </a:solidFill>
+                <a:latin typeface="Malgun Gothic" pitchFamily="34" charset="0"/>
+                <a:ea typeface="Malgun Gothic" pitchFamily="34" charset="-122"/>
+                <a:cs typeface="Malgun Gothic" pitchFamily="34" charset="-120"/>
+              </a:rPr>
+              <a:t>Android · iOS의 카메라 정밀 제어 공식 API</a:t>
+            </a:r>
+            <a:endParaRPr lang="en-US" sz="900" dirty="0"/>
+          </a:p>
+        </p:txBody>
+      </p:sp>
+      <p:sp>
+        <p:nvSpPr>
+          <p:cNvPr id="59" name="Text 57"/>
+          <p:cNvSpPr/>
+          <p:nvPr/>
+        </p:nvSpPr>
+        <p:spPr>
+          <a:xfrm>
+            <a:off x="6507328" y="5856732"/>
+            <a:ext cx="2377440" cy="297180"/>
+          </a:xfrm>
+          <a:prstGeom prst="rect">
+            <a:avLst/>
+          </a:prstGeom>
+          <a:noFill/>
+          <a:ln/>
+        </p:spPr>
+        <p:txBody>
+          <a:bodyPr wrap="square" rtlCol="0" anchor="t"/>
+          <a:lstStyle/>
+          <a:p>
+            <a:pPr indent="0" marL="0">
+              <a:buNone/>
+            </a:pPr>
+            <a:r>
+              <a:rPr lang="en-US" sz="1000" b="1" dirty="0">
+                <a:solidFill>
+                  <a:srgbClr val="1A2B3C"/>
+                </a:solidFill>
+                <a:latin typeface="Malgun Gothic" pitchFamily="34" charset="0"/>
+                <a:ea typeface="Malgun Gothic" pitchFamily="34" charset="-122"/>
+                <a:cs typeface="Malgun Gothic" pitchFamily="34" charset="-120"/>
+              </a:rPr>
+              <a:t>SDK</a:t>
+            </a:r>
+            <a:endParaRPr lang="en-US" sz="1000" dirty="0"/>
+          </a:p>
+        </p:txBody>
+      </p:sp>
+      <p:sp>
+        <p:nvSpPr>
+          <p:cNvPr id="60" name="Text 58"/>
+          <p:cNvSpPr/>
+          <p:nvPr/>
+        </p:nvSpPr>
+        <p:spPr>
+          <a:xfrm>
+            <a:off x="8930488" y="5856732"/>
+            <a:ext cx="2666848" cy="297180"/>
+          </a:xfrm>
+          <a:prstGeom prst="rect">
+            <a:avLst/>
+          </a:prstGeom>
+          <a:noFill/>
+          <a:ln/>
+        </p:spPr>
+        <p:txBody>
+          <a:bodyPr wrap="square" rtlCol="0" anchor="t"/>
+          <a:lstStyle/>
+          <a:p>
+            <a:pPr indent="0" marL="0">
+              <a:buNone/>
+            </a:pPr>
+            <a:r>
+              <a:rPr lang="en-US" sz="900" dirty="0">
+                <a:solidFill>
+                  <a:srgbClr val="6B7785"/>
+                </a:solidFill>
+                <a:latin typeface="Malgun Gothic" pitchFamily="34" charset="0"/>
+                <a:ea typeface="Malgun Gothic" pitchFamily="34" charset="-122"/>
+                <a:cs typeface="Malgun Gothic" pitchFamily="34" charset="-120"/>
+              </a:rPr>
+              <a:t>Software Development Kit — 외부 개발자가 쓸 수 있게 만든 기능 묶음</a:t>
             </a:r>
             <a:endParaRPr lang="en-US" sz="900" dirty="0"/>
           </a:p>

</xml_diff>